<commit_message>
Add collective communication implementation plans
</commit_message>
<xml_diff>
--- a/export/moe_route_flowchart.pptx
+++ b/export/moe_route_flowchart.pptx
@@ -3098,57 +3098,14 @@
       <p:grpSpPr/>
       <p:sp>
         <p:nvSpPr>
-          <p:cNvPr id="2" name="Rectangle 1"/>
-          <p:cNvSpPr/>
-          <p:nvPr/>
-        </p:nvSpPr>
-        <p:spPr>
-          <a:xfrm>
-            <a:off x="0" y="0"/>
-            <a:ext cx="12191695" cy="32004"/>
-          </a:xfrm>
-          <a:prstGeom prst="rect">
-            <a:avLst/>
-          </a:prstGeom>
-          <a:solidFill>
-            <a:srgbClr val="111111"/>
-          </a:solidFill>
-          <a:ln>
-            <a:noFill/>
-          </a:ln>
-        </p:spPr>
-        <p:style>
-          <a:lnRef idx="1">
-            <a:schemeClr val="accent1"/>
-          </a:lnRef>
-          <a:fillRef idx="3">
-            <a:schemeClr val="accent1"/>
-          </a:fillRef>
-          <a:effectRef idx="2">
-            <a:schemeClr val="accent1"/>
-          </a:effectRef>
-          <a:fontRef idx="minor">
-            <a:schemeClr val="lt1"/>
-          </a:fontRef>
-        </p:style>
-        <p:txBody>
-          <a:bodyPr rtlCol="0" anchor="ctr"/>
-          <a:lstStyle/>
-          <a:p>
-            <a:pPr algn="ctr"/>
-          </a:p>
-        </p:txBody>
-      </p:sp>
-      <p:sp>
-        <p:nvSpPr>
-          <p:cNvPr id="3" name="TextBox 2"/>
+          <p:cNvPr id="2" name="TextBox 1"/>
           <p:cNvSpPr txBox="1"/>
           <p:nvPr/>
         </p:nvSpPr>
         <p:spPr>
           <a:xfrm>
-            <a:off x="502920" y="182880"/>
-            <a:ext cx="11155680" cy="347472"/>
+            <a:off x="384048" y="109728"/>
+            <a:ext cx="11384280" cy="365760"/>
           </a:xfrm>
           <a:prstGeom prst="rect">
             <a:avLst/>
@@ -3178,25 +3135,25 @@
             <a:r>
               <a:rPr sz="2200" b="0">
                 <a:solidFill>
-                  <a:srgbClr val="111111"/>
+                  <a:srgbClr val="C00000"/>
                 </a:solidFill>
                 <a:latin typeface="Microsoft YaHei"/>
               </a:rPr>
-              <a:t>WD3：Token 选专家后的多核执行（组队可选）</a:t>
-            </a:r>
-          </a:p>
-        </p:txBody>
-      </p:sp>
-      <p:sp>
-        <p:nvSpPr>
-          <p:cNvPr id="4" name="TextBox 3"/>
+              <a:t>WD3：多核 MoE 激活计算（Token 选专家后）</a:t>
+            </a:r>
+          </a:p>
+        </p:txBody>
+      </p:sp>
+      <p:sp>
+        <p:nvSpPr>
+          <p:cNvPr id="3" name="TextBox 2"/>
           <p:cNvSpPr txBox="1"/>
           <p:nvPr/>
         </p:nvSpPr>
         <p:spPr>
           <a:xfrm>
-            <a:off x="521207" y="585216"/>
-            <a:ext cx="10972800" cy="182880"/>
+            <a:off x="411480" y="512064"/>
+            <a:ext cx="11201400" cy="164592"/>
           </a:xfrm>
           <a:prstGeom prst="rect">
             <a:avLst/>
@@ -3224,27 +3181,27 @@
               </a:spcAft>
             </a:pPr>
             <a:r>
-              <a:rPr sz="919" b="0">
+              <a:rPr sz="880" b="0">
                 <a:solidFill>
                   <a:srgbClr val="555555"/>
                 </a:solidFill>
                 <a:latin typeface="Microsoft YaHei"/>
               </a:rPr>
-              <a:t>前提：每个 token 的 Top-K expert_id 与混合权重 α 已给定；流程从 dispatch 开始</a:t>
-            </a:r>
-          </a:p>
-        </p:txBody>
-      </p:sp>
-      <p:sp>
-        <p:nvSpPr>
-          <p:cNvPr id="5" name="Rectangle 4"/>
+              <a:t>前提：X=[x_t]、I=[e_t,k]、A=[α_t,k] 已给定；流程从 dispatch 开始</a:t>
+            </a:r>
+          </a:p>
+        </p:txBody>
+      </p:sp>
+      <p:sp>
+        <p:nvSpPr>
+          <p:cNvPr id="4" name="Rectangle 3"/>
           <p:cNvSpPr/>
           <p:nvPr/>
         </p:nvSpPr>
         <p:spPr>
           <a:xfrm>
-            <a:off x="502920" y="859536"/>
-            <a:ext cx="2057400" cy="594360"/>
+            <a:off x="347472" y="768096"/>
+            <a:ext cx="1920240" cy="548640"/>
           </a:xfrm>
           <a:prstGeom prst="rect">
             <a:avLst/>
@@ -3273,39 +3230,29 @@
           </a:fontRef>
         </p:style>
         <p:txBody>
-          <a:bodyPr rtlCol="0" anchor="ctr"/>
-          <a:lstStyle/>
-          <a:p>
-            <a:pPr algn="ctr"/>
-          </a:p>
-        </p:txBody>
-      </p:sp>
-      <p:sp>
-        <p:nvSpPr>
-          <p:cNvPr id="6" name="TextBox 5"/>
-          <p:cNvSpPr txBox="1"/>
-          <p:nvPr/>
-        </p:nvSpPr>
-        <p:spPr>
-          <a:xfrm>
-            <a:off x="649224" y="914400"/>
-            <a:ext cx="1764792" cy="182880"/>
-          </a:xfrm>
-          <a:prstGeom prst="rect">
-            <a:avLst/>
-          </a:prstGeom>
-          <a:noFill/>
-          <a:ln>
-            <a:noFill/>
-          </a:ln>
-        </p:spPr>
-        <p:txBody>
-          <a:bodyPr wrap="square" lIns="0" rIns="0" tIns="0" bIns="0" anchor="ctr">
-            <a:spAutoFit/>
-          </a:bodyPr>
-          <a:lstStyle/>
-          <a:p>
-            <a:pPr algn="ctr">
+          <a:bodyPr rtlCol="0" anchor="t" wrap="square" lIns="127000" rIns="127000" tIns="88900" bIns="76200"/>
+          <a:lstStyle/>
+          <a:p>
+            <a:pPr algn="l">
+              <a:spcBef>
+                <a:spcPts val="0"/>
+              </a:spcBef>
+              <a:spcAft>
+                <a:spcPts val="600"/>
+              </a:spcAft>
+            </a:pPr>
+            <a:r>
+              <a:rPr sz="940" b="1">
+                <a:solidFill>
+                  <a:srgbClr val="111111"/>
+                </a:solidFill>
+                <a:latin typeface="Microsoft YaHei"/>
+              </a:rPr>
+              <a:t>内存足够策略</a:t>
+            </a:r>
+          </a:p>
+          <a:p>
+            <a:pPr algn="l">
               <a:lnSpc>
                 <a:spcPct val="100000"/>
               </a:lnSpc>
@@ -3313,47 +3260,21 @@
                 <a:spcPts val="0"/>
               </a:spcBef>
               <a:spcAft>
-                <a:spcPts val="0"/>
+                <a:spcPts val="200"/>
               </a:spcAft>
             </a:pPr>
             <a:r>
-              <a:rPr sz="950" b="1">
+              <a:rPr sz="750" b="0">
                 <a:solidFill>
                   <a:srgbClr val="111111"/>
                 </a:solidFill>
                 <a:latin typeface="Microsoft YaHei"/>
               </a:rPr>
-              <a:t>内存足够策略</a:t>
-            </a:r>
-          </a:p>
-        </p:txBody>
-      </p:sp>
-      <p:sp>
-        <p:nvSpPr>
-          <p:cNvPr id="7" name="TextBox 6"/>
-          <p:cNvSpPr txBox="1"/>
-          <p:nvPr/>
-        </p:nvSpPr>
-        <p:spPr>
-          <a:xfrm>
-            <a:off x="649224" y="1115568"/>
-            <a:ext cx="1764792" cy="219456"/>
-          </a:xfrm>
-          <a:prstGeom prst="rect">
-            <a:avLst/>
-          </a:prstGeom>
-          <a:noFill/>
-          <a:ln>
-            <a:noFill/>
-          </a:ln>
-        </p:spPr>
-        <p:txBody>
-          <a:bodyPr wrap="square" lIns="0" rIns="0" tIns="0" bIns="0" anchor="ctr">
-            <a:spAutoFit/>
-          </a:bodyPr>
-          <a:lstStyle/>
-          <a:p>
-            <a:pPr algn="ctr">
+              <a:t>core r 固定持有 E_r</a:t>
+            </a:r>
+          </a:p>
+          <a:p>
+            <a:pPr algn="l">
               <a:lnSpc>
                 <a:spcPct val="100000"/>
               </a:lnSpc>
@@ -3361,50 +3282,63 @@
                 <a:spcPts val="0"/>
               </a:spcBef>
               <a:spcAft>
-                <a:spcPts val="0"/>
+                <a:spcPts val="200"/>
               </a:spcAft>
             </a:pPr>
             <a:r>
-              <a:rPr sz="819" b="1">
+              <a:rPr sz="750" b="0">
                 <a:solidFill>
                   <a:srgbClr val="111111"/>
                 </a:solidFill>
-                <a:latin typeface="Aptos"/>
+                <a:latin typeface="Microsoft YaHei"/>
               </a:rPr>
-              <a:t>core r 固定持有 E_r</a:t>
-            </a:r>
-          </a:p>
-        </p:txBody>
-      </p:sp>
-      <p:sp>
-        <p:nvSpPr>
-          <p:cNvPr id="8" name="TextBox 7"/>
-          <p:cNvSpPr txBox="1"/>
+              <a:t>W_e 常驻</a:t>
+            </a:r>
+          </a:p>
+        </p:txBody>
+      </p:sp>
+      <p:sp>
+        <p:nvSpPr>
+          <p:cNvPr id="5" name="Rectangle 4"/>
+          <p:cNvSpPr/>
           <p:nvPr/>
         </p:nvSpPr>
         <p:spPr>
           <a:xfrm>
-            <a:off x="649224" y="1234439"/>
-            <a:ext cx="1764792" cy="155448"/>
+            <a:off x="2523744" y="768096"/>
+            <a:ext cx="5870448" cy="548640"/>
           </a:xfrm>
           <a:prstGeom prst="rect">
             <a:avLst/>
           </a:prstGeom>
-          <a:noFill/>
-          <a:ln>
-            <a:noFill/>
+          <a:solidFill>
+            <a:srgbClr val="FFFFFF"/>
+          </a:solidFill>
+          <a:ln w="13970">
+            <a:solidFill>
+              <a:srgbClr val="111111"/>
+            </a:solidFill>
           </a:ln>
         </p:spPr>
-        <p:txBody>
-          <a:bodyPr wrap="square" lIns="0" rIns="0" tIns="0" bIns="0" anchor="ctr">
-            <a:spAutoFit/>
-          </a:bodyPr>
+        <p:style>
+          <a:lnRef idx="1">
+            <a:schemeClr val="accent1"/>
+          </a:lnRef>
+          <a:fillRef idx="3">
+            <a:schemeClr val="accent1"/>
+          </a:fillRef>
+          <a:effectRef idx="2">
+            <a:schemeClr val="accent1"/>
+          </a:effectRef>
+          <a:fontRef idx="minor">
+            <a:schemeClr val="lt1"/>
+          </a:fontRef>
+        </p:style>
+        <p:txBody>
+          <a:bodyPr rtlCol="0" anchor="ctr" wrap="none" lIns="127000" rIns="127000" tIns="0" bIns="0"/>
           <a:lstStyle/>
           <a:p>
             <a:pPr algn="ctr">
-              <a:lnSpc>
-                <a:spcPct val="100000"/>
-              </a:lnSpc>
               <a:spcBef>
                 <a:spcPts val="0"/>
               </a:spcBef>
@@ -3413,27 +3347,27 @@
               </a:spcAft>
             </a:pPr>
             <a:r>
-              <a:rPr sz="700" b="0">
-                <a:solidFill>
-                  <a:srgbClr val="555555"/>
+              <a:rPr sz="1450" b="1">
+                <a:solidFill>
+                  <a:srgbClr val="111111"/>
                 </a:solidFill>
                 <a:latin typeface="Microsoft YaHei"/>
               </a:rPr>
-              <a:t>专家参数 W_e 常驻</a:t>
-            </a:r>
-          </a:p>
-        </p:txBody>
-      </p:sp>
-      <p:sp>
-        <p:nvSpPr>
-          <p:cNvPr id="9" name="Rectangle 8"/>
+              <a:t>输入（已知）：Tokens + Top-K expert_id + α</a:t>
+            </a:r>
+          </a:p>
+        </p:txBody>
+      </p:sp>
+      <p:sp>
+        <p:nvSpPr>
+          <p:cNvPr id="6" name="Rectangle 5"/>
           <p:cNvSpPr/>
           <p:nvPr/>
         </p:nvSpPr>
         <p:spPr>
           <a:xfrm>
-            <a:off x="2743200" y="859536"/>
-            <a:ext cx="6583680" cy="594360"/>
+            <a:off x="9912096" y="768096"/>
+            <a:ext cx="1920240" cy="548640"/>
           </a:xfrm>
           <a:prstGeom prst="rect">
             <a:avLst/>
@@ -3462,23 +3396,144 @@
           </a:fontRef>
         </p:style>
         <p:txBody>
-          <a:bodyPr rtlCol="0" anchor="ctr"/>
-          <a:lstStyle/>
-          <a:p>
-            <a:pPr algn="ctr"/>
-          </a:p>
-        </p:txBody>
-      </p:sp>
-      <p:sp>
-        <p:nvSpPr>
-          <p:cNvPr id="10" name="TextBox 9"/>
+          <a:bodyPr rtlCol="0" anchor="t" wrap="square" lIns="127000" rIns="127000" tIns="88900" bIns="76200"/>
+          <a:lstStyle/>
+          <a:p>
+            <a:pPr algn="l">
+              <a:spcBef>
+                <a:spcPts val="0"/>
+              </a:spcBef>
+              <a:spcAft>
+                <a:spcPts val="600"/>
+              </a:spcAft>
+            </a:pPr>
+            <a:r>
+              <a:rPr sz="940" b="1">
+                <a:solidFill>
+                  <a:srgbClr val="111111"/>
+                </a:solidFill>
+                <a:latin typeface="Microsoft YaHei"/>
+              </a:rPr>
+              <a:t>内存不足策略</a:t>
+            </a:r>
+          </a:p>
+          <a:p>
+            <a:pPr algn="l">
+              <a:lnSpc>
+                <a:spcPct val="100000"/>
+              </a:lnSpc>
+              <a:spcBef>
+                <a:spcPts val="0"/>
+              </a:spcBef>
+              <a:spcAft>
+                <a:spcPts val="200"/>
+              </a:spcAft>
+            </a:pPr>
+            <a:r>
+              <a:rPr sz="750" b="0">
+                <a:solidFill>
+                  <a:srgbClr val="111111"/>
+                </a:solidFill>
+                <a:latin typeface="Microsoft YaHei"/>
+              </a:rPr>
+              <a:t>U=unique({e_t,k})</a:t>
+            </a:r>
+          </a:p>
+          <a:p>
+            <a:pPr algn="l">
+              <a:lnSpc>
+                <a:spcPct val="100000"/>
+              </a:lnSpc>
+              <a:spcBef>
+                <a:spcPts val="0"/>
+              </a:spcBef>
+              <a:spcAft>
+                <a:spcPts val="200"/>
+              </a:spcAft>
+            </a:pPr>
+            <a:r>
+              <a:rPr sz="750" b="0">
+                <a:solidFill>
+                  <a:srgbClr val="111111"/>
+                </a:solidFill>
+                <a:latin typeface="Microsoft YaHei"/>
+              </a:rPr>
+              <a:t>按批动态加载</a:t>
+            </a:r>
+          </a:p>
+        </p:txBody>
+      </p:sp>
+      <p:sp>
+        <p:nvSpPr>
+          <p:cNvPr id="7" name="Rectangle 6"/>
+          <p:cNvSpPr/>
+          <p:nvPr/>
+        </p:nvSpPr>
+        <p:spPr>
+          <a:xfrm>
+            <a:off x="713232" y="1517904"/>
+            <a:ext cx="8138160" cy="365760"/>
+          </a:xfrm>
+          <a:prstGeom prst="rect">
+            <a:avLst/>
+          </a:prstGeom>
+          <a:solidFill>
+            <a:srgbClr val="FFFFFF"/>
+          </a:solidFill>
+          <a:ln w="13970">
+            <a:solidFill>
+              <a:srgbClr val="111111"/>
+            </a:solidFill>
+          </a:ln>
+        </p:spPr>
+        <p:style>
+          <a:lnRef idx="1">
+            <a:schemeClr val="accent1"/>
+          </a:lnRef>
+          <a:fillRef idx="3">
+            <a:schemeClr val="accent1"/>
+          </a:fillRef>
+          <a:effectRef idx="2">
+            <a:schemeClr val="accent1"/>
+          </a:effectRef>
+          <a:fontRef idx="minor">
+            <a:schemeClr val="lt1"/>
+          </a:fontRef>
+        </p:style>
+        <p:txBody>
+          <a:bodyPr rtlCol="0" anchor="ctr" wrap="none" lIns="127000" rIns="127000" tIns="0" bIns="0"/>
+          <a:lstStyle/>
+          <a:p>
+            <a:pPr algn="ctr">
+              <a:spcBef>
+                <a:spcPts val="0"/>
+              </a:spcBef>
+              <a:spcAft>
+                <a:spcPts val="0"/>
+              </a:spcAft>
+            </a:pPr>
+            <a:r>
+              <a:rPr sz="1520" b="1">
+                <a:solidFill>
+                  <a:srgbClr val="111111"/>
+                </a:solidFill>
+                <a:latin typeface="Microsoft YaHei"/>
+              </a:rPr>
+              <a:t>准备本地专家集合</a:t>
+            </a:r>
+          </a:p>
+        </p:txBody>
+      </p:sp>
+      <p:sp>
+        <p:nvSpPr>
+          <p:cNvPr id="8" name="TextBox 7"/>
           <p:cNvSpPr txBox="1"/>
           <p:nvPr/>
         </p:nvSpPr>
         <p:spPr>
           <a:xfrm>
-            <a:off x="2889504" y="914400"/>
-            <a:ext cx="6291072" cy="182880"/>
+            <a:off x="859536" y="1920240"/>
+            <a:ext cx="7845552" cy="146304"/>
           </a:xfrm>
           <a:prstGeom prst="rect">
             <a:avLst/>
@@ -3506,27 +3561,110 @@
               </a:spcAft>
             </a:pPr>
             <a:r>
-              <a:rPr sz="1000" b="1">
+              <a:rPr sz="790" b="1">
                 <a:solidFill>
                   <a:srgbClr val="111111"/>
+                </a:solidFill>
+                <a:latin typeface="Consolas"/>
+              </a:rPr>
+              <a:t>E_r；W_e={W1^e,W2^e,W3^e}</a:t>
+            </a:r>
+          </a:p>
+          <a:p>
+            <a:pPr algn="ctr">
+              <a:lnSpc>
+                <a:spcPct val="100000"/>
+              </a:lnSpc>
+              <a:spcBef>
+                <a:spcPts val="100"/>
+              </a:spcBef>
+              <a:spcAft>
+                <a:spcPts val="0"/>
+              </a:spcAft>
+            </a:pPr>
+            <a:r>
+              <a:rPr sz="700" b="0">
+                <a:solidFill>
+                  <a:srgbClr val="555555"/>
                 </a:solidFill>
                 <a:latin typeface="Microsoft YaHei"/>
               </a:rPr>
-              <a:t>输入（已知）</a:t>
-            </a:r>
-          </a:p>
-        </p:txBody>
-      </p:sp>
-      <p:sp>
-        <p:nvSpPr>
-          <p:cNvPr id="11" name="TextBox 10"/>
+              <a:t>每个 core 只执行 E_r</a:t>
+            </a:r>
+          </a:p>
+        </p:txBody>
+      </p:sp>
+      <p:sp>
+        <p:nvSpPr>
+          <p:cNvPr id="9" name="Rectangle 8"/>
+          <p:cNvSpPr/>
+          <p:nvPr/>
+        </p:nvSpPr>
+        <p:spPr>
+          <a:xfrm>
+            <a:off x="713232" y="2176272"/>
+            <a:ext cx="8138160" cy="365760"/>
+          </a:xfrm>
+          <a:prstGeom prst="rect">
+            <a:avLst/>
+          </a:prstGeom>
+          <a:solidFill>
+            <a:srgbClr val="FFFFFF"/>
+          </a:solidFill>
+          <a:ln w="13970">
+            <a:solidFill>
+              <a:srgbClr val="111111"/>
+            </a:solidFill>
+          </a:ln>
+        </p:spPr>
+        <p:style>
+          <a:lnRef idx="1">
+            <a:schemeClr val="accent1"/>
+          </a:lnRef>
+          <a:fillRef idx="3">
+            <a:schemeClr val="accent1"/>
+          </a:fillRef>
+          <a:effectRef idx="2">
+            <a:schemeClr val="accent1"/>
+          </a:effectRef>
+          <a:fontRef idx="minor">
+            <a:schemeClr val="lt1"/>
+          </a:fontRef>
+        </p:style>
+        <p:txBody>
+          <a:bodyPr rtlCol="0" anchor="ctr" wrap="none" lIns="127000" rIns="127000" tIns="0" bIns="0"/>
+          <a:lstStyle/>
+          <a:p>
+            <a:pPr algn="ctr">
+              <a:spcBef>
+                <a:spcPts val="0"/>
+              </a:spcBef>
+              <a:spcAft>
+                <a:spcPts val="0"/>
+              </a:spcAft>
+            </a:pPr>
+            <a:r>
+              <a:rPr sz="1520" b="1">
+                <a:solidFill>
+                  <a:srgbClr val="111111"/>
+                </a:solidFill>
+                <a:latin typeface="Microsoft YaHei"/>
+              </a:rPr>
+              <a:t>Token 与路由表分发</a:t>
+            </a:r>
+          </a:p>
+        </p:txBody>
+      </p:sp>
+      <p:sp>
+        <p:nvSpPr>
+          <p:cNvPr id="10" name="TextBox 9"/>
           <p:cNvSpPr txBox="1"/>
           <p:nvPr/>
         </p:nvSpPr>
         <p:spPr>
           <a:xfrm>
-            <a:off x="2889504" y="1115568"/>
-            <a:ext cx="6291072" cy="219456"/>
+            <a:off x="859536" y="2578608"/>
+            <a:ext cx="7845552" cy="146304"/>
           </a:xfrm>
           <a:prstGeom prst="rect">
             <a:avLst/>
@@ -3554,13 +3692,96 @@
               </a:spcAft>
             </a:pPr>
             <a:r>
-              <a:rPr sz="880" b="1">
+              <a:rPr sz="790" b="1">
                 <a:solidFill>
                   <a:srgbClr val="111111"/>
                 </a:solidFill>
-                <a:latin typeface="Aptos"/>
+                <a:latin typeface="Consolas"/>
               </a:rPr>
-              <a:t>X=[x_t]  ·  I=[e_t,k]  ·  A=[α_t,k]</a:t>
+              <a:t>R={(t,e_t,k,α_t,k)}</a:t>
+            </a:r>
+          </a:p>
+          <a:p>
+            <a:pPr algn="ctr">
+              <a:lnSpc>
+                <a:spcPct val="100000"/>
+              </a:lnSpc>
+              <a:spcBef>
+                <a:spcPts val="100"/>
+              </a:spcBef>
+              <a:spcAft>
+                <a:spcPts val="0"/>
+              </a:spcAft>
+            </a:pPr>
+            <a:r>
+              <a:rPr sz="700" b="0">
+                <a:solidFill>
+                  <a:srgbClr val="555555"/>
+                </a:solidFill>
+                <a:latin typeface="Microsoft YaHei"/>
+              </a:rPr>
+              <a:t>广播到各 core，也可 all-to-all</a:t>
+            </a:r>
+          </a:p>
+        </p:txBody>
+      </p:sp>
+      <p:sp>
+        <p:nvSpPr>
+          <p:cNvPr id="11" name="Rectangle 10"/>
+          <p:cNvSpPr/>
+          <p:nvPr/>
+        </p:nvSpPr>
+        <p:spPr>
+          <a:xfrm>
+            <a:off x="713232" y="2834640"/>
+            <a:ext cx="8138160" cy="365760"/>
+          </a:xfrm>
+          <a:prstGeom prst="rect">
+            <a:avLst/>
+          </a:prstGeom>
+          <a:solidFill>
+            <a:srgbClr val="FFFFFF"/>
+          </a:solidFill>
+          <a:ln w="13970">
+            <a:solidFill>
+              <a:srgbClr val="111111"/>
+            </a:solidFill>
+          </a:ln>
+        </p:spPr>
+        <p:style>
+          <a:lnRef idx="1">
+            <a:schemeClr val="accent1"/>
+          </a:lnRef>
+          <a:fillRef idx="3">
+            <a:schemeClr val="accent1"/>
+          </a:fillRef>
+          <a:effectRef idx="2">
+            <a:schemeClr val="accent1"/>
+          </a:effectRef>
+          <a:fontRef idx="minor">
+            <a:schemeClr val="lt1"/>
+          </a:fontRef>
+        </p:style>
+        <p:txBody>
+          <a:bodyPr rtlCol="0" anchor="ctr" wrap="none" lIns="127000" rIns="127000" tIns="0" bIns="0"/>
+          <a:lstStyle/>
+          <a:p>
+            <a:pPr algn="ctr">
+              <a:spcBef>
+                <a:spcPts val="0"/>
+              </a:spcBef>
+              <a:spcAft>
+                <a:spcPts val="0"/>
+              </a:spcAft>
+            </a:pPr>
+            <a:r>
+              <a:rPr sz="1520" b="1">
+                <a:solidFill>
+                  <a:srgbClr val="111111"/>
+                </a:solidFill>
+                <a:latin typeface="Microsoft YaHei"/>
+              </a:rPr>
+              <a:t>按 expert_id 组队</a:t>
             </a:r>
           </a:p>
         </p:txBody>
@@ -3573,8 +3794,8 @@
         </p:nvSpPr>
         <p:spPr>
           <a:xfrm>
-            <a:off x="2889504" y="1234439"/>
-            <a:ext cx="6291072" cy="155448"/>
+            <a:off x="859536" y="3236976"/>
+            <a:ext cx="7845552" cy="146304"/>
           </a:xfrm>
           <a:prstGeom prst="rect">
             <a:avLst/>
@@ -3602,13 +3823,35 @@
               </a:spcAft>
             </a:pPr>
             <a:r>
-              <a:rPr sz="720" b="0">
+              <a:rPr sz="790" b="1">
+                <a:solidFill>
+                  <a:srgbClr val="111111"/>
+                </a:solidFill>
+                <a:latin typeface="Consolas"/>
+              </a:rPr>
+              <a:t>G_{r,e}={(t,x_t,α_t,k):e_t,k=e}</a:t>
+            </a:r>
+          </a:p>
+          <a:p>
+            <a:pPr algn="ctr">
+              <a:lnSpc>
+                <a:spcPct val="100000"/>
+              </a:lnSpc>
+              <a:spcBef>
+                <a:spcPts val="100"/>
+              </a:spcBef>
+              <a:spcAft>
+                <a:spcPts val="0"/>
+              </a:spcAft>
+            </a:pPr>
+            <a:r>
+              <a:rPr sz="700" b="0">
                 <a:solidFill>
                   <a:srgbClr val="555555"/>
                 </a:solidFill>
                 <a:latin typeface="Microsoft YaHei"/>
               </a:rPr>
-              <a:t>T 个 token；每个 token 已有 K 个 expert_id 与混合权重</a:t>
+              <a:t>同一 expert_id 的 token 成 batch</a:t>
             </a:r>
           </a:p>
         </p:txBody>
@@ -3621,8 +3864,532 @@
         </p:nvSpPr>
         <p:spPr>
           <a:xfrm>
-            <a:off x="9646920" y="859536"/>
-            <a:ext cx="2057400" cy="594360"/>
+            <a:off x="713232" y="3493008"/>
+            <a:ext cx="8138160" cy="438912"/>
+          </a:xfrm>
+          <a:prstGeom prst="rect">
+            <a:avLst/>
+          </a:prstGeom>
+          <a:solidFill>
+            <a:srgbClr val="FFFFFF"/>
+          </a:solidFill>
+          <a:ln w="13970">
+            <a:solidFill>
+              <a:srgbClr val="111111"/>
+            </a:solidFill>
+          </a:ln>
+        </p:spPr>
+        <p:style>
+          <a:lnRef idx="1">
+            <a:schemeClr val="accent1"/>
+          </a:lnRef>
+          <a:fillRef idx="3">
+            <a:schemeClr val="accent1"/>
+          </a:fillRef>
+          <a:effectRef idx="2">
+            <a:schemeClr val="accent1"/>
+          </a:effectRef>
+          <a:fontRef idx="minor">
+            <a:schemeClr val="lt1"/>
+          </a:fontRef>
+        </p:style>
+        <p:txBody>
+          <a:bodyPr rtlCol="0" anchor="ctr" wrap="none" lIns="127000" rIns="127000" tIns="0" bIns="0"/>
+          <a:lstStyle/>
+          <a:p>
+            <a:pPr algn="ctr">
+              <a:spcBef>
+                <a:spcPts val="0"/>
+              </a:spcBef>
+              <a:spcAft>
+                <a:spcPts val="0"/>
+              </a:spcAft>
+            </a:pPr>
+            <a:r>
+              <a:rPr sz="1520" b="1">
+                <a:solidFill>
+                  <a:srgbClr val="111111"/>
+                </a:solidFill>
+                <a:latin typeface="Microsoft YaHei"/>
+              </a:rPr>
+              <a:t>本地 Expert 批量计算</a:t>
+            </a:r>
+          </a:p>
+        </p:txBody>
+      </p:sp>
+      <p:sp>
+        <p:nvSpPr>
+          <p:cNvPr id="14" name="TextBox 13"/>
+          <p:cNvSpPr txBox="1"/>
+          <p:nvPr/>
+        </p:nvSpPr>
+        <p:spPr>
+          <a:xfrm>
+            <a:off x="859536" y="3968496"/>
+            <a:ext cx="7845552" cy="201168"/>
+          </a:xfrm>
+          <a:prstGeom prst="rect">
+            <a:avLst/>
+          </a:prstGeom>
+          <a:noFill/>
+          <a:ln>
+            <a:noFill/>
+          </a:ln>
+        </p:spPr>
+        <p:txBody>
+          <a:bodyPr wrap="square" lIns="0" rIns="0" tIns="0" bIns="0" anchor="ctr">
+            <a:spAutoFit/>
+          </a:bodyPr>
+          <a:lstStyle/>
+          <a:p>
+            <a:pPr algn="ctr">
+              <a:lnSpc>
+                <a:spcPct val="100000"/>
+              </a:lnSpc>
+              <a:spcBef>
+                <a:spcPts val="0"/>
+              </a:spcBef>
+              <a:spcAft>
+                <a:spcPts val="0"/>
+              </a:spcAft>
+            </a:pPr>
+            <a:r>
+              <a:rPr sz="790" b="1">
+                <a:solidFill>
+                  <a:srgbClr val="111111"/>
+                </a:solidFill>
+                <a:latin typeface="Consolas"/>
+              </a:rPr>
+              <a:t>h=SiLU(xW1)⊙(xW3);  y=W2(α·h)</a:t>
+            </a:r>
+          </a:p>
+          <a:p>
+            <a:pPr algn="ctr">
+              <a:lnSpc>
+                <a:spcPct val="100000"/>
+              </a:lnSpc>
+              <a:spcBef>
+                <a:spcPts val="100"/>
+              </a:spcBef>
+              <a:spcAft>
+                <a:spcPts val="0"/>
+              </a:spcAft>
+            </a:pPr>
+            <a:r>
+              <a:rPr sz="700" b="0">
+                <a:solidFill>
+                  <a:srgbClr val="555555"/>
+                </a:solidFill>
+                <a:latin typeface="Microsoft YaHei"/>
+              </a:rPr>
+              <a:t>α 乘在 activated 上</a:t>
+            </a:r>
+          </a:p>
+        </p:txBody>
+      </p:sp>
+      <p:sp>
+        <p:nvSpPr>
+          <p:cNvPr id="15" name="Rectangle 14"/>
+          <p:cNvSpPr/>
+          <p:nvPr/>
+        </p:nvSpPr>
+        <p:spPr>
+          <a:xfrm>
+            <a:off x="713232" y="4352544"/>
+            <a:ext cx="8138160" cy="365760"/>
+          </a:xfrm>
+          <a:prstGeom prst="rect">
+            <a:avLst/>
+          </a:prstGeom>
+          <a:solidFill>
+            <a:srgbClr val="FFFFFF"/>
+          </a:solidFill>
+          <a:ln w="13970">
+            <a:solidFill>
+              <a:srgbClr val="111111"/>
+            </a:solidFill>
+          </a:ln>
+        </p:spPr>
+        <p:style>
+          <a:lnRef idx="1">
+            <a:schemeClr val="accent1"/>
+          </a:lnRef>
+          <a:fillRef idx="3">
+            <a:schemeClr val="accent1"/>
+          </a:fillRef>
+          <a:effectRef idx="2">
+            <a:schemeClr val="accent1"/>
+          </a:effectRef>
+          <a:fontRef idx="minor">
+            <a:schemeClr val="lt1"/>
+          </a:fontRef>
+        </p:style>
+        <p:txBody>
+          <a:bodyPr rtlCol="0" anchor="ctr" wrap="none" lIns="127000" rIns="127000" tIns="0" bIns="0"/>
+          <a:lstStyle/>
+          <a:p>
+            <a:pPr algn="ctr">
+              <a:spcBef>
+                <a:spcPts val="0"/>
+              </a:spcBef>
+              <a:spcAft>
+                <a:spcPts val="0"/>
+              </a:spcAft>
+            </a:pPr>
+            <a:r>
+              <a:rPr sz="1520" b="1">
+                <a:solidFill>
+                  <a:srgbClr val="111111"/>
+                </a:solidFill>
+                <a:latin typeface="Microsoft YaHei"/>
+              </a:rPr>
+              <a:t>按 token_pos 归位</a:t>
+            </a:r>
+          </a:p>
+        </p:txBody>
+      </p:sp>
+      <p:sp>
+        <p:nvSpPr>
+          <p:cNvPr id="16" name="TextBox 15"/>
+          <p:cNvSpPr txBox="1"/>
+          <p:nvPr/>
+        </p:nvSpPr>
+        <p:spPr>
+          <a:xfrm>
+            <a:off x="859536" y="4754880"/>
+            <a:ext cx="7845552" cy="146304"/>
+          </a:xfrm>
+          <a:prstGeom prst="rect">
+            <a:avLst/>
+          </a:prstGeom>
+          <a:noFill/>
+          <a:ln>
+            <a:noFill/>
+          </a:ln>
+        </p:spPr>
+        <p:txBody>
+          <a:bodyPr wrap="square" lIns="0" rIns="0" tIns="0" bIns="0" anchor="ctr">
+            <a:spAutoFit/>
+          </a:bodyPr>
+          <a:lstStyle/>
+          <a:p>
+            <a:pPr algn="ctr">
+              <a:lnSpc>
+                <a:spcPct val="100000"/>
+              </a:lnSpc>
+              <a:spcBef>
+                <a:spcPts val="0"/>
+              </a:spcBef>
+              <a:spcAft>
+                <a:spcPts val="0"/>
+              </a:spcAft>
+            </a:pPr>
+            <a:r>
+              <a:rPr sz="790" b="1">
+                <a:solidFill>
+                  <a:srgbClr val="111111"/>
+                </a:solidFill>
+                <a:latin typeface="Consolas"/>
+              </a:rPr>
+              <a:t>y_r[t] += y_t,e</a:t>
+            </a:r>
+          </a:p>
+          <a:p>
+            <a:pPr algn="ctr">
+              <a:lnSpc>
+                <a:spcPct val="100000"/>
+              </a:lnSpc>
+              <a:spcBef>
+                <a:spcPts val="100"/>
+              </a:spcBef>
+              <a:spcAft>
+                <a:spcPts val="0"/>
+              </a:spcAft>
+            </a:pPr>
+            <a:r>
+              <a:rPr sz="700" b="0">
+                <a:solidFill>
+                  <a:srgbClr val="555555"/>
+                </a:solidFill>
+                <a:latin typeface="Microsoft YaHei"/>
+              </a:rPr>
+              <a:t>index_add_(0, token_index, routed)</a:t>
+            </a:r>
+          </a:p>
+        </p:txBody>
+      </p:sp>
+      <p:sp>
+        <p:nvSpPr>
+          <p:cNvPr id="17" name="Rectangle 16"/>
+          <p:cNvSpPr/>
+          <p:nvPr/>
+        </p:nvSpPr>
+        <p:spPr>
+          <a:xfrm>
+            <a:off x="713232" y="5010912"/>
+            <a:ext cx="8138160" cy="365760"/>
+          </a:xfrm>
+          <a:prstGeom prst="rect">
+            <a:avLst/>
+          </a:prstGeom>
+          <a:solidFill>
+            <a:srgbClr val="FFFFFF"/>
+          </a:solidFill>
+          <a:ln w="13970">
+            <a:solidFill>
+              <a:srgbClr val="111111"/>
+            </a:solidFill>
+          </a:ln>
+        </p:spPr>
+        <p:style>
+          <a:lnRef idx="1">
+            <a:schemeClr val="accent1"/>
+          </a:lnRef>
+          <a:fillRef idx="3">
+            <a:schemeClr val="accent1"/>
+          </a:fillRef>
+          <a:effectRef idx="2">
+            <a:schemeClr val="accent1"/>
+          </a:effectRef>
+          <a:fontRef idx="minor">
+            <a:schemeClr val="lt1"/>
+          </a:fontRef>
+        </p:style>
+        <p:txBody>
+          <a:bodyPr rtlCol="0" anchor="ctr" wrap="none" lIns="127000" rIns="127000" tIns="0" bIns="0"/>
+          <a:lstStyle/>
+          <a:p>
+            <a:pPr algn="ctr">
+              <a:spcBef>
+                <a:spcPts val="0"/>
+              </a:spcBef>
+              <a:spcAft>
+                <a:spcPts val="0"/>
+              </a:spcAft>
+            </a:pPr>
+            <a:r>
+              <a:rPr sz="1520" b="1">
+                <a:solidFill>
+                  <a:srgbClr val="111111"/>
+                </a:solidFill>
+                <a:latin typeface="Microsoft YaHei"/>
+              </a:rPr>
+              <a:t>Routed 结果 AllReduce</a:t>
+            </a:r>
+          </a:p>
+        </p:txBody>
+      </p:sp>
+      <p:sp>
+        <p:nvSpPr>
+          <p:cNvPr id="18" name="TextBox 17"/>
+          <p:cNvSpPr txBox="1"/>
+          <p:nvPr/>
+        </p:nvSpPr>
+        <p:spPr>
+          <a:xfrm>
+            <a:off x="859536" y="5413248"/>
+            <a:ext cx="7845552" cy="146304"/>
+          </a:xfrm>
+          <a:prstGeom prst="rect">
+            <a:avLst/>
+          </a:prstGeom>
+          <a:noFill/>
+          <a:ln>
+            <a:noFill/>
+          </a:ln>
+        </p:spPr>
+        <p:txBody>
+          <a:bodyPr wrap="square" lIns="0" rIns="0" tIns="0" bIns="0" anchor="ctr">
+            <a:spAutoFit/>
+          </a:bodyPr>
+          <a:lstStyle/>
+          <a:p>
+            <a:pPr algn="ctr">
+              <a:lnSpc>
+                <a:spcPct val="100000"/>
+              </a:lnSpc>
+              <a:spcBef>
+                <a:spcPts val="0"/>
+              </a:spcBef>
+              <a:spcAft>
+                <a:spcPts val="0"/>
+              </a:spcAft>
+            </a:pPr>
+            <a:r>
+              <a:rPr sz="790" b="1">
+                <a:solidFill>
+                  <a:srgbClr val="111111"/>
+                </a:solidFill>
+                <a:latin typeface="Consolas"/>
+              </a:rPr>
+              <a:t>y_routed[t]=Σ_r y_r[t]</a:t>
+            </a:r>
+          </a:p>
+          <a:p>
+            <a:pPr algn="ctr">
+              <a:lnSpc>
+                <a:spcPct val="100000"/>
+              </a:lnSpc>
+              <a:spcBef>
+                <a:spcPts val="100"/>
+              </a:spcBef>
+              <a:spcAft>
+                <a:spcPts val="0"/>
+              </a:spcAft>
+            </a:pPr>
+            <a:r>
+              <a:rPr sz="700" b="0">
+                <a:solidFill>
+                  <a:srgbClr val="555555"/>
+                </a:solidFill>
+                <a:latin typeface="Microsoft YaHei"/>
+              </a:rPr>
+              <a:t>逐 token、逐维求和；只汇总 routed</a:t>
+            </a:r>
+          </a:p>
+        </p:txBody>
+      </p:sp>
+      <p:sp>
+        <p:nvSpPr>
+          <p:cNvPr id="19" name="Rectangle 18"/>
+          <p:cNvSpPr/>
+          <p:nvPr/>
+        </p:nvSpPr>
+        <p:spPr>
+          <a:xfrm>
+            <a:off x="713232" y="5669280"/>
+            <a:ext cx="8138160" cy="384048"/>
+          </a:xfrm>
+          <a:prstGeom prst="rect">
+            <a:avLst/>
+          </a:prstGeom>
+          <a:solidFill>
+            <a:srgbClr val="FFFFFF"/>
+          </a:solidFill>
+          <a:ln w="13970">
+            <a:solidFill>
+              <a:srgbClr val="111111"/>
+            </a:solidFill>
+          </a:ln>
+        </p:spPr>
+        <p:style>
+          <a:lnRef idx="1">
+            <a:schemeClr val="accent1"/>
+          </a:lnRef>
+          <a:fillRef idx="3">
+            <a:schemeClr val="accent1"/>
+          </a:fillRef>
+          <a:effectRef idx="2">
+            <a:schemeClr val="accent1"/>
+          </a:effectRef>
+          <a:fontRef idx="minor">
+            <a:schemeClr val="lt1"/>
+          </a:fontRef>
+        </p:style>
+        <p:txBody>
+          <a:bodyPr rtlCol="0" anchor="ctr" wrap="none" lIns="127000" rIns="127000" tIns="0" bIns="0"/>
+          <a:lstStyle/>
+          <a:p>
+            <a:pPr algn="ctr">
+              <a:spcBef>
+                <a:spcPts val="0"/>
+              </a:spcBef>
+              <a:spcAft>
+                <a:spcPts val="0"/>
+              </a:spcAft>
+            </a:pPr>
+            <a:r>
+              <a:rPr sz="1520" b="1">
+                <a:solidFill>
+                  <a:srgbClr val="111111"/>
+                </a:solidFill>
+                <a:latin typeface="Microsoft YaHei"/>
+              </a:rPr>
+              <a:t>加 Shared Expert，输出结果</a:t>
+            </a:r>
+          </a:p>
+        </p:txBody>
+      </p:sp>
+      <p:sp>
+        <p:nvSpPr>
+          <p:cNvPr id="20" name="TextBox 19"/>
+          <p:cNvSpPr txBox="1"/>
+          <p:nvPr/>
+        </p:nvSpPr>
+        <p:spPr>
+          <a:xfrm>
+            <a:off x="859536" y="6089904"/>
+            <a:ext cx="7845552" cy="146304"/>
+          </a:xfrm>
+          <a:prstGeom prst="rect">
+            <a:avLst/>
+          </a:prstGeom>
+          <a:noFill/>
+          <a:ln>
+            <a:noFill/>
+          </a:ln>
+        </p:spPr>
+        <p:txBody>
+          <a:bodyPr wrap="square" lIns="0" rIns="0" tIns="0" bIns="0" anchor="ctr">
+            <a:spAutoFit/>
+          </a:bodyPr>
+          <a:lstStyle/>
+          <a:p>
+            <a:pPr algn="ctr">
+              <a:lnSpc>
+                <a:spcPct val="100000"/>
+              </a:lnSpc>
+              <a:spcBef>
+                <a:spcPts val="0"/>
+              </a:spcBef>
+              <a:spcAft>
+                <a:spcPts val="0"/>
+              </a:spcAft>
+            </a:pPr>
+            <a:r>
+              <a:rPr sz="790" b="1">
+                <a:solidFill>
+                  <a:srgbClr val="111111"/>
+                </a:solidFill>
+                <a:latin typeface="Consolas"/>
+              </a:rPr>
+              <a:t>y[t]=y_routed[t]+y_shared[t]</a:t>
+            </a:r>
+          </a:p>
+          <a:p>
+            <a:pPr algn="ctr">
+              <a:lnSpc>
+                <a:spcPct val="100000"/>
+              </a:lnSpc>
+              <a:spcBef>
+                <a:spcPts val="100"/>
+              </a:spcBef>
+              <a:spcAft>
+                <a:spcPts val="0"/>
+              </a:spcAft>
+            </a:pPr>
+            <a:r>
+              <a:rPr sz="700" b="0">
+                <a:solidFill>
+                  <a:srgbClr val="555555"/>
+                </a:solidFill>
+                <a:latin typeface="Microsoft YaHei"/>
+              </a:rPr>
+              <a:t>[T,D] → [B,S,D] → HC post</a:t>
+            </a:r>
+          </a:p>
+        </p:txBody>
+      </p:sp>
+      <p:sp>
+        <p:nvSpPr>
+          <p:cNvPr id="21" name="Rectangle 20"/>
+          <p:cNvSpPr/>
+          <p:nvPr/>
+        </p:nvSpPr>
+        <p:spPr>
+          <a:xfrm>
+            <a:off x="9162288" y="1481328"/>
+            <a:ext cx="2761488" cy="960120"/>
           </a:xfrm>
           <a:prstGeom prst="rect">
             <a:avLst/>
@@ -3651,39 +4418,29 @@
           </a:fontRef>
         </p:style>
         <p:txBody>
-          <a:bodyPr rtlCol="0" anchor="ctr"/>
-          <a:lstStyle/>
-          <a:p>
-            <a:pPr algn="ctr"/>
-          </a:p>
-        </p:txBody>
-      </p:sp>
-      <p:sp>
-        <p:nvSpPr>
-          <p:cNvPr id="14" name="TextBox 13"/>
-          <p:cNvSpPr txBox="1"/>
-          <p:nvPr/>
-        </p:nvSpPr>
-        <p:spPr>
-          <a:xfrm>
-            <a:off x="9793224" y="914400"/>
-            <a:ext cx="1764792" cy="182880"/>
-          </a:xfrm>
-          <a:prstGeom prst="rect">
-            <a:avLst/>
-          </a:prstGeom>
-          <a:noFill/>
-          <a:ln>
-            <a:noFill/>
-          </a:ln>
-        </p:spPr>
-        <p:txBody>
-          <a:bodyPr wrap="square" lIns="0" rIns="0" tIns="0" bIns="0" anchor="ctr">
-            <a:spAutoFit/>
-          </a:bodyPr>
-          <a:lstStyle/>
-          <a:p>
-            <a:pPr algn="ctr">
+          <a:bodyPr rtlCol="0" anchor="t" wrap="square" lIns="127000" rIns="127000" tIns="88900" bIns="76200"/>
+          <a:lstStyle/>
+          <a:p>
+            <a:pPr algn="l">
+              <a:spcBef>
+                <a:spcPts val="0"/>
+              </a:spcBef>
+              <a:spcAft>
+                <a:spcPts val="600"/>
+              </a:spcAft>
+            </a:pPr>
+            <a:r>
+              <a:rPr sz="1050" b="1">
+                <a:solidFill>
+                  <a:srgbClr val="111111"/>
+                </a:solidFill>
+                <a:latin typeface="Microsoft YaHei"/>
+              </a:rPr>
+              <a:t>实现代码</a:t>
+            </a:r>
+          </a:p>
+          <a:p>
+            <a:pPr algn="l">
               <a:lnSpc>
                 <a:spcPct val="100000"/>
               </a:lnSpc>
@@ -3691,47 +4448,21 @@
                 <a:spcPts val="0"/>
               </a:spcBef>
               <a:spcAft>
-                <a:spcPts val="0"/>
+                <a:spcPts val="200"/>
               </a:spcAft>
             </a:pPr>
             <a:r>
-              <a:rPr sz="950" b="1">
+              <a:rPr sz="700" b="0">
                 <a:solidFill>
                   <a:srgbClr val="111111"/>
                 </a:solidFill>
-                <a:latin typeface="Microsoft YaHei"/>
+                <a:latin typeface="Consolas"/>
               </a:rPr>
-              <a:t>内存不足策略</a:t>
-            </a:r>
-          </a:p>
-        </p:txBody>
-      </p:sp>
-      <p:sp>
-        <p:nvSpPr>
-          <p:cNvPr id="15" name="TextBox 14"/>
-          <p:cNvSpPr txBox="1"/>
-          <p:nvPr/>
-        </p:nvSpPr>
-        <p:spPr>
-          <a:xfrm>
-            <a:off x="9793224" y="1115568"/>
-            <a:ext cx="1764792" cy="219456"/>
-          </a:xfrm>
-          <a:prstGeom prst="rect">
-            <a:avLst/>
-          </a:prstGeom>
-          <a:noFill/>
-          <a:ln>
-            <a:noFill/>
-          </a:ln>
-        </p:spPr>
-        <p:txBody>
-          <a:bodyPr wrap="square" lIns="0" rIns="0" tIns="0" bIns="0" anchor="ctr">
-            <a:spAutoFit/>
-          </a:bodyPr>
-          <a:lstStyle/>
-          <a:p>
-            <a:pPr algn="ctr">
+              <a:t>idx,top=where(I==e)</a:t>
+            </a:r>
+          </a:p>
+          <a:p>
+            <a:pPr algn="l">
               <a:lnSpc>
                 <a:spcPct val="100000"/>
               </a:lnSpc>
@@ -3739,47 +4470,21 @@
                 <a:spcPts val="0"/>
               </a:spcBef>
               <a:spcAft>
-                <a:spcPts val="0"/>
+                <a:spcPts val="200"/>
               </a:spcAft>
             </a:pPr>
             <a:r>
-              <a:rPr sz="819" b="1">
+              <a:rPr sz="700" b="0">
                 <a:solidFill>
                   <a:srgbClr val="111111"/>
                 </a:solidFill>
-                <a:latin typeface="Aptos"/>
+                <a:latin typeface="Consolas"/>
               </a:rPr>
-              <a:t>U=unique({e_t,k})</a:t>
-            </a:r>
-          </a:p>
-        </p:txBody>
-      </p:sp>
-      <p:sp>
-        <p:nvSpPr>
-          <p:cNvPr id="16" name="TextBox 15"/>
-          <p:cNvSpPr txBox="1"/>
-          <p:nvPr/>
-        </p:nvSpPr>
-        <p:spPr>
-          <a:xfrm>
-            <a:off x="9793224" y="1234439"/>
-            <a:ext cx="1764792" cy="155448"/>
-          </a:xfrm>
-          <a:prstGeom prst="rect">
-            <a:avLst/>
-          </a:prstGeom>
-          <a:noFill/>
-          <a:ln>
-            <a:noFill/>
-          </a:ln>
-        </p:spPr>
-        <p:txBody>
-          <a:bodyPr wrap="square" lIns="0" rIns="0" tIns="0" bIns="0" anchor="ctr">
-            <a:spAutoFit/>
-          </a:bodyPr>
-          <a:lstStyle/>
-          <a:p>
-            <a:pPr algn="ctr">
+              <a:t>routed=Expert(X[idx], A[idx,top])</a:t>
+            </a:r>
+          </a:p>
+          <a:p>
+            <a:pPr algn="l">
               <a:lnSpc>
                 <a:spcPct val="100000"/>
               </a:lnSpc>
@@ -3787,31 +4492,31 @@
                 <a:spcPts val="0"/>
               </a:spcBef>
               <a:spcAft>
-                <a:spcPts val="0"/>
+                <a:spcPts val="200"/>
               </a:spcAft>
             </a:pPr>
             <a:r>
               <a:rPr sz="700" b="0">
                 <a:solidFill>
-                  <a:srgbClr val="555555"/>
-                </a:solidFill>
-                <a:latin typeface="Microsoft YaHei"/>
+                  <a:srgbClr val="111111"/>
+                </a:solidFill>
+                <a:latin typeface="Consolas"/>
               </a:rPr>
-              <a:t>按当前批次动态加载</a:t>
-            </a:r>
-          </a:p>
-        </p:txBody>
-      </p:sp>
-      <p:sp>
-        <p:nvSpPr>
-          <p:cNvPr id="17" name="Rectangle 16"/>
+              <a:t>每个 expert 形成一个 batch</a:t>
+            </a:r>
+          </a:p>
+        </p:txBody>
+      </p:sp>
+      <p:sp>
+        <p:nvSpPr>
+          <p:cNvPr id="22" name="Rectangle 21"/>
           <p:cNvSpPr/>
           <p:nvPr/>
         </p:nvSpPr>
         <p:spPr>
           <a:xfrm>
-            <a:off x="2743200" y="1600200"/>
-            <a:ext cx="6583680" cy="493776"/>
+            <a:off x="9162288" y="2679192"/>
+            <a:ext cx="2761488" cy="1353312"/>
           </a:xfrm>
           <a:prstGeom prst="rect">
             <a:avLst/>
@@ -3840,23 +4545,188 @@
           </a:fontRef>
         </p:style>
         <p:txBody>
-          <a:bodyPr rtlCol="0" anchor="ctr"/>
-          <a:lstStyle/>
-          <a:p>
-            <a:pPr algn="ctr"/>
-          </a:p>
-        </p:txBody>
-      </p:sp>
-      <p:sp>
-        <p:nvSpPr>
-          <p:cNvPr id="18" name="TextBox 17"/>
+          <a:bodyPr rtlCol="0" anchor="t" wrap="square" lIns="127000" rIns="127000" tIns="88900" bIns="76200"/>
+          <a:lstStyle/>
+          <a:p>
+            <a:pPr algn="l">
+              <a:spcBef>
+                <a:spcPts val="0"/>
+              </a:spcBef>
+              <a:spcAft>
+                <a:spcPts val="600"/>
+              </a:spcAft>
+            </a:pPr>
+            <a:r>
+              <a:rPr sz="1050" b="1">
+                <a:solidFill>
+                  <a:srgbClr val="111111"/>
+                </a:solidFill>
+                <a:latin typeface="Microsoft YaHei"/>
+              </a:rPr>
+              <a:t>组队示意</a:t>
+            </a:r>
+          </a:p>
+          <a:p>
+            <a:pPr algn="l">
+              <a:lnSpc>
+                <a:spcPct val="100000"/>
+              </a:lnSpc>
+              <a:spcBef>
+                <a:spcPts val="0"/>
+              </a:spcBef>
+              <a:spcAft>
+                <a:spcPts val="200"/>
+              </a:spcAft>
+            </a:pPr>
+            <a:r>
+              <a:rPr sz="720" b="0">
+                <a:solidFill>
+                  <a:srgbClr val="111111"/>
+                </a:solidFill>
+                <a:latin typeface="Consolas"/>
+              </a:rPr>
+              <a:t>e_0 :  t_0   t_3</a:t>
+            </a:r>
+          </a:p>
+          <a:p>
+            <a:pPr algn="l">
+              <a:lnSpc>
+                <a:spcPct val="100000"/>
+              </a:lnSpc>
+              <a:spcBef>
+                <a:spcPts val="0"/>
+              </a:spcBef>
+              <a:spcAft>
+                <a:spcPts val="200"/>
+              </a:spcAft>
+            </a:pPr>
+            <a:r>
+              <a:rPr sz="720" b="0">
+                <a:solidFill>
+                  <a:srgbClr val="111111"/>
+                </a:solidFill>
+                <a:latin typeface="Consolas"/>
+              </a:rPr>
+              <a:t>e_1 :  t_1   t_2   t_4</a:t>
+            </a:r>
+          </a:p>
+          <a:p>
+            <a:pPr algn="l">
+              <a:lnSpc>
+                <a:spcPct val="100000"/>
+              </a:lnSpc>
+              <a:spcBef>
+                <a:spcPts val="0"/>
+              </a:spcBef>
+              <a:spcAft>
+                <a:spcPts val="200"/>
+              </a:spcAft>
+            </a:pPr>
+            <a:r>
+              <a:rPr sz="720" b="0">
+                <a:solidFill>
+                  <a:srgbClr val="111111"/>
+                </a:solidFill>
+                <a:latin typeface="Consolas"/>
+              </a:rPr>
+              <a:t>e_2 :  t_0   t_2</a:t>
+            </a:r>
+          </a:p>
+          <a:p>
+            <a:pPr algn="l">
+              <a:lnSpc>
+                <a:spcPct val="100000"/>
+              </a:lnSpc>
+              <a:spcBef>
+                <a:spcPts val="0"/>
+              </a:spcBef>
+              <a:spcAft>
+                <a:spcPts val="200"/>
+              </a:spcAft>
+            </a:pPr>
+            <a:r>
+              <a:rPr sz="720" b="0">
+                <a:solidFill>
+                  <a:srgbClr val="111111"/>
+                </a:solidFill>
+                <a:latin typeface="Consolas"/>
+              </a:rPr>
+              <a:t>同一 expert_id 一队</a:t>
+            </a:r>
+          </a:p>
+        </p:txBody>
+      </p:sp>
+      <p:sp>
+        <p:nvSpPr>
+          <p:cNvPr id="23" name="Rectangle 22"/>
+          <p:cNvSpPr/>
+          <p:nvPr/>
+        </p:nvSpPr>
+        <p:spPr>
+          <a:xfrm>
+            <a:off x="9162288" y="4828032"/>
+            <a:ext cx="2761488" cy="457200"/>
+          </a:xfrm>
+          <a:prstGeom prst="rect">
+            <a:avLst/>
+          </a:prstGeom>
+          <a:solidFill>
+            <a:srgbClr val="FFFFFF"/>
+          </a:solidFill>
+          <a:ln w="13970">
+            <a:solidFill>
+              <a:srgbClr val="111111"/>
+            </a:solidFill>
+          </a:ln>
+        </p:spPr>
+        <p:style>
+          <a:lnRef idx="1">
+            <a:schemeClr val="accent1"/>
+          </a:lnRef>
+          <a:fillRef idx="3">
+            <a:schemeClr val="accent1"/>
+          </a:fillRef>
+          <a:effectRef idx="2">
+            <a:schemeClr val="accent1"/>
+          </a:effectRef>
+          <a:fontRef idx="minor">
+            <a:schemeClr val="lt1"/>
+          </a:fontRef>
+        </p:style>
+        <p:txBody>
+          <a:bodyPr rtlCol="0" anchor="ctr" wrap="none" lIns="127000" rIns="127000" tIns="0" bIns="0"/>
+          <a:lstStyle/>
+          <a:p>
+            <a:pPr algn="ctr">
+              <a:spcBef>
+                <a:spcPts val="0"/>
+              </a:spcBef>
+              <a:spcAft>
+                <a:spcPts val="0"/>
+              </a:spcAft>
+            </a:pPr>
+            <a:r>
+              <a:rPr sz="1080" b="1">
+                <a:solidFill>
+                  <a:srgbClr val="111111"/>
+                </a:solidFill>
+                <a:latin typeface="Microsoft YaHei"/>
+              </a:rPr>
+              <a:t>Shared Expert（always on）</a:t>
+            </a:r>
+          </a:p>
+        </p:txBody>
+      </p:sp>
+      <p:sp>
+        <p:nvSpPr>
+          <p:cNvPr id="24" name="TextBox 23"/>
           <p:cNvSpPr txBox="1"/>
           <p:nvPr/>
         </p:nvSpPr>
         <p:spPr>
           <a:xfrm>
-            <a:off x="2889504" y="1655064"/>
-            <a:ext cx="6291072" cy="182880"/>
+            <a:off x="9235440" y="5330952"/>
+            <a:ext cx="2615184" cy="256032"/>
           </a:xfrm>
           <a:prstGeom prst="rect">
             <a:avLst/>
@@ -3884,1436 +4754,29 @@
               </a:spcAft>
             </a:pPr>
             <a:r>
-              <a:rPr sz="950" b="1">
+              <a:rPr sz="780" b="1">
                 <a:solidFill>
                   <a:srgbClr val="111111"/>
                 </a:solidFill>
-                <a:latin typeface="Microsoft YaHei"/>
+                <a:latin typeface="Consolas"/>
               </a:rPr>
-              <a:t>每核确定本地专家集合，并准备专家参数</a:t>
-            </a:r>
-          </a:p>
-        </p:txBody>
-      </p:sp>
-      <p:sp>
-        <p:nvSpPr>
-          <p:cNvPr id="19" name="TextBox 18"/>
-          <p:cNvSpPr txBox="1"/>
-          <p:nvPr/>
-        </p:nvSpPr>
-        <p:spPr>
-          <a:xfrm>
-            <a:off x="2889504" y="1856232"/>
-            <a:ext cx="6291072" cy="219456"/>
-          </a:xfrm>
-          <a:prstGeom prst="rect">
-            <a:avLst/>
-          </a:prstGeom>
-          <a:noFill/>
-          <a:ln>
-            <a:noFill/>
-          </a:ln>
-        </p:spPr>
-        <p:txBody>
-          <a:bodyPr wrap="square" lIns="0" rIns="0" tIns="0" bIns="0" anchor="ctr">
-            <a:spAutoFit/>
-          </a:bodyPr>
-          <a:lstStyle/>
+              <a:t>y_shared[t]=S(x_t)</a:t>
+            </a:r>
+          </a:p>
           <a:p>
             <a:pPr algn="ctr">
               <a:lnSpc>
                 <a:spcPct val="100000"/>
               </a:lnSpc>
               <a:spcBef>
-                <a:spcPts val="0"/>
+                <a:spcPts val="100"/>
               </a:spcBef>
               <a:spcAft>
                 <a:spcPts val="0"/>
               </a:spcAft>
             </a:pPr>
             <a:r>
-              <a:rPr sz="790" b="1">
-                <a:solidFill>
-                  <a:srgbClr val="111111"/>
-                </a:solidFill>
-                <a:latin typeface="Aptos"/>
-              </a:rPr>
-              <a:t>E = ⋃_r E_r  ·  W_e={W1^e,W2^e,W3^e}</a:t>
-            </a:r>
-          </a:p>
-        </p:txBody>
-      </p:sp>
-      <p:sp>
-        <p:nvSpPr>
-          <p:cNvPr id="20" name="TextBox 19"/>
-          <p:cNvSpPr txBox="1"/>
-          <p:nvPr/>
-        </p:nvSpPr>
-        <p:spPr>
-          <a:xfrm>
-            <a:off x="2889504" y="1874519"/>
-            <a:ext cx="6291072" cy="155448"/>
-          </a:xfrm>
-          <a:prstGeom prst="rect">
-            <a:avLst/>
-          </a:prstGeom>
-          <a:noFill/>
-          <a:ln>
-            <a:noFill/>
-          </a:ln>
-        </p:spPr>
-        <p:txBody>
-          <a:bodyPr wrap="square" lIns="0" rIns="0" tIns="0" bIns="0" anchor="ctr">
-            <a:spAutoFit/>
-          </a:bodyPr>
-          <a:lstStyle/>
-          <a:p>
-            <a:pPr algn="ctr">
-              <a:lnSpc>
-                <a:spcPct val="100000"/>
-              </a:lnSpc>
-              <a:spcBef>
-                <a:spcPts val="0"/>
-              </a:spcBef>
-              <a:spcAft>
-                <a:spcPts val="0"/>
-              </a:spcAft>
-            </a:pPr>
-            <a:r>
-              <a:rPr sz="700" b="0">
-                <a:solidFill>
-                  <a:srgbClr val="555555"/>
-                </a:solidFill>
-                <a:latin typeface="Microsoft YaHei"/>
-              </a:rPr>
-              <a:t>A 是混合权重；W_e 是专家参数</a:t>
-            </a:r>
-          </a:p>
-        </p:txBody>
-      </p:sp>
-      <p:sp>
-        <p:nvSpPr>
-          <p:cNvPr id="21" name="Rectangle 20"/>
-          <p:cNvSpPr/>
-          <p:nvPr/>
-        </p:nvSpPr>
-        <p:spPr>
-          <a:xfrm>
-            <a:off x="2743200" y="2258568"/>
-            <a:ext cx="6583680" cy="493776"/>
-          </a:xfrm>
-          <a:prstGeom prst="rect">
-            <a:avLst/>
-          </a:prstGeom>
-          <a:solidFill>
-            <a:srgbClr val="FFFFFF"/>
-          </a:solidFill>
-          <a:ln w="12700">
-            <a:solidFill>
-              <a:srgbClr val="111111"/>
-            </a:solidFill>
-          </a:ln>
-        </p:spPr>
-        <p:style>
-          <a:lnRef idx="1">
-            <a:schemeClr val="accent1"/>
-          </a:lnRef>
-          <a:fillRef idx="3">
-            <a:schemeClr val="accent1"/>
-          </a:fillRef>
-          <a:effectRef idx="2">
-            <a:schemeClr val="accent1"/>
-          </a:effectRef>
-          <a:fontRef idx="minor">
-            <a:schemeClr val="lt1"/>
-          </a:fontRef>
-        </p:style>
-        <p:txBody>
-          <a:bodyPr rtlCol="0" anchor="ctr"/>
-          <a:lstStyle/>
-          <a:p>
-            <a:pPr algn="ctr"/>
-          </a:p>
-        </p:txBody>
-      </p:sp>
-      <p:sp>
-        <p:nvSpPr>
-          <p:cNvPr id="22" name="TextBox 21"/>
-          <p:cNvSpPr txBox="1"/>
-          <p:nvPr/>
-        </p:nvSpPr>
-        <p:spPr>
-          <a:xfrm>
-            <a:off x="2889504" y="2313432"/>
-            <a:ext cx="6291072" cy="182880"/>
-          </a:xfrm>
-          <a:prstGeom prst="rect">
-            <a:avLst/>
-          </a:prstGeom>
-          <a:noFill/>
-          <a:ln>
-            <a:noFill/>
-          </a:ln>
-        </p:spPr>
-        <p:txBody>
-          <a:bodyPr wrap="square" lIns="0" rIns="0" tIns="0" bIns="0" anchor="ctr">
-            <a:spAutoFit/>
-          </a:bodyPr>
-          <a:lstStyle/>
-          <a:p>
-            <a:pPr algn="ctr">
-              <a:lnSpc>
-                <a:spcPct val="100000"/>
-              </a:lnSpc>
-              <a:spcBef>
-                <a:spcPts val="0"/>
-              </a:spcBef>
-              <a:spcAft>
-                <a:spcPts val="0"/>
-              </a:spcAft>
-            </a:pPr>
-            <a:r>
-              <a:rPr sz="969" b="1">
-                <a:solidFill>
-                  <a:srgbClr val="111111"/>
-                </a:solidFill>
-                <a:latin typeface="Microsoft YaHei"/>
-              </a:rPr>
-              <a:t>Tokens + 全局路由表，广播给所有 core</a:t>
-            </a:r>
-          </a:p>
-        </p:txBody>
-      </p:sp>
-      <p:sp>
-        <p:nvSpPr>
-          <p:cNvPr id="23" name="TextBox 22"/>
-          <p:cNvSpPr txBox="1"/>
-          <p:nvPr/>
-        </p:nvSpPr>
-        <p:spPr>
-          <a:xfrm>
-            <a:off x="2889504" y="2514600"/>
-            <a:ext cx="6291072" cy="219456"/>
-          </a:xfrm>
-          <a:prstGeom prst="rect">
-            <a:avLst/>
-          </a:prstGeom>
-          <a:noFill/>
-          <a:ln>
-            <a:noFill/>
-          </a:ln>
-        </p:spPr>
-        <p:txBody>
-          <a:bodyPr wrap="square" lIns="0" rIns="0" tIns="0" bIns="0" anchor="ctr">
-            <a:spAutoFit/>
-          </a:bodyPr>
-          <a:lstStyle/>
-          <a:p>
-            <a:pPr algn="ctr">
-              <a:lnSpc>
-                <a:spcPct val="100000"/>
-              </a:lnSpc>
-              <a:spcBef>
-                <a:spcPts val="0"/>
-              </a:spcBef>
-              <a:spcAft>
-                <a:spcPts val="0"/>
-              </a:spcAft>
-            </a:pPr>
-            <a:r>
-              <a:rPr sz="850" b="1">
-                <a:solidFill>
-                  <a:srgbClr val="111111"/>
-                </a:solidFill>
-                <a:latin typeface="Aptos"/>
-              </a:rPr>
-              <a:t>R = {(t, e_t,k, α_t,k)}</a:t>
-            </a:r>
-          </a:p>
-        </p:txBody>
-      </p:sp>
-      <p:sp>
-        <p:nvSpPr>
-          <p:cNvPr id="24" name="TextBox 23"/>
-          <p:cNvSpPr txBox="1"/>
-          <p:nvPr/>
-        </p:nvSpPr>
-        <p:spPr>
-          <a:xfrm>
-            <a:off x="2889504" y="2532888"/>
-            <a:ext cx="6291072" cy="155448"/>
-          </a:xfrm>
-          <a:prstGeom prst="rect">
-            <a:avLst/>
-          </a:prstGeom>
-          <a:noFill/>
-          <a:ln>
-            <a:noFill/>
-          </a:ln>
-        </p:spPr>
-        <p:txBody>
-          <a:bodyPr wrap="square" lIns="0" rIns="0" tIns="0" bIns="0" anchor="ctr">
-            <a:spAutoFit/>
-          </a:bodyPr>
-          <a:lstStyle/>
-          <a:p>
-            <a:pPr algn="ctr">
-              <a:lnSpc>
-                <a:spcPct val="100000"/>
-              </a:lnSpc>
-              <a:spcBef>
-                <a:spcPts val="0"/>
-              </a:spcBef>
-              <a:spcAft>
-                <a:spcPts val="0"/>
-              </a:spcAft>
-            </a:pPr>
-            <a:r>
-              <a:rPr sz="700" b="0">
-                <a:solidFill>
-                  <a:srgbClr val="555555"/>
-                </a:solidFill>
-                <a:latin typeface="Microsoft YaHei"/>
-              </a:rPr>
-              <a:t>也可用 all-to-all，只发送给目标 core</a:t>
-            </a:r>
-          </a:p>
-        </p:txBody>
-      </p:sp>
-      <p:sp>
-        <p:nvSpPr>
-          <p:cNvPr id="25" name="Rectangle 24"/>
-          <p:cNvSpPr/>
-          <p:nvPr/>
-        </p:nvSpPr>
-        <p:spPr>
-          <a:xfrm>
-            <a:off x="2743200" y="2916936"/>
-            <a:ext cx="6583680" cy="612648"/>
-          </a:xfrm>
-          <a:prstGeom prst="rect">
-            <a:avLst/>
-          </a:prstGeom>
-          <a:solidFill>
-            <a:srgbClr val="FFFFFF"/>
-          </a:solidFill>
-          <a:ln w="12700">
-            <a:solidFill>
-              <a:srgbClr val="111111"/>
-            </a:solidFill>
-          </a:ln>
-        </p:spPr>
-        <p:style>
-          <a:lnRef idx="1">
-            <a:schemeClr val="accent1"/>
-          </a:lnRef>
-          <a:fillRef idx="3">
-            <a:schemeClr val="accent1"/>
-          </a:fillRef>
-          <a:effectRef idx="2">
-            <a:schemeClr val="accent1"/>
-          </a:effectRef>
-          <a:fontRef idx="minor">
-            <a:schemeClr val="lt1"/>
-          </a:fontRef>
-        </p:style>
-        <p:txBody>
-          <a:bodyPr rtlCol="0" anchor="ctr"/>
-          <a:lstStyle/>
-          <a:p>
-            <a:pPr algn="ctr"/>
-          </a:p>
-        </p:txBody>
-      </p:sp>
-      <p:sp>
-        <p:nvSpPr>
-          <p:cNvPr id="26" name="TextBox 25"/>
-          <p:cNvSpPr txBox="1"/>
-          <p:nvPr/>
-        </p:nvSpPr>
-        <p:spPr>
-          <a:xfrm>
-            <a:off x="2889504" y="2971800"/>
-            <a:ext cx="6291072" cy="182880"/>
-          </a:xfrm>
-          <a:prstGeom prst="rect">
-            <a:avLst/>
-          </a:prstGeom>
-          <a:noFill/>
-          <a:ln>
-            <a:noFill/>
-          </a:ln>
-        </p:spPr>
-        <p:txBody>
-          <a:bodyPr wrap="square" lIns="0" rIns="0" tIns="0" bIns="0" anchor="ctr">
-            <a:spAutoFit/>
-          </a:bodyPr>
-          <a:lstStyle/>
-          <a:p>
-            <a:pPr algn="ctr">
-              <a:lnSpc>
-                <a:spcPct val="100000"/>
-              </a:lnSpc>
-              <a:spcBef>
-                <a:spcPts val="0"/>
-              </a:spcBef>
-              <a:spcAft>
-                <a:spcPts val="0"/>
-              </a:spcAft>
-            </a:pPr>
-            <a:r>
-              <a:rPr sz="969" b="1">
-                <a:solidFill>
-                  <a:srgbClr val="111111"/>
-                </a:solidFill>
-                <a:latin typeface="Microsoft YaHei"/>
-              </a:rPr>
-              <a:t>按 expert_id 筛选、分桶，组成 Token 小队</a:t>
-            </a:r>
-          </a:p>
-        </p:txBody>
-      </p:sp>
-      <p:sp>
-        <p:nvSpPr>
-          <p:cNvPr id="27" name="TextBox 26"/>
-          <p:cNvSpPr txBox="1"/>
-          <p:nvPr/>
-        </p:nvSpPr>
-        <p:spPr>
-          <a:xfrm>
-            <a:off x="2889504" y="3172968"/>
-            <a:ext cx="6291072" cy="219456"/>
-          </a:xfrm>
-          <a:prstGeom prst="rect">
-            <a:avLst/>
-          </a:prstGeom>
-          <a:noFill/>
-          <a:ln>
-            <a:noFill/>
-          </a:ln>
-        </p:spPr>
-        <p:txBody>
-          <a:bodyPr wrap="square" lIns="0" rIns="0" tIns="0" bIns="0" anchor="ctr">
-            <a:spAutoFit/>
-          </a:bodyPr>
-          <a:lstStyle/>
-          <a:p>
-            <a:pPr algn="ctr">
-              <a:lnSpc>
-                <a:spcPct val="100000"/>
-              </a:lnSpc>
-              <a:spcBef>
-                <a:spcPts val="0"/>
-              </a:spcBef>
-              <a:spcAft>
-                <a:spcPts val="0"/>
-              </a:spcAft>
-            </a:pPr>
-            <a:r>
-              <a:rPr sz="740" b="1">
-                <a:solidFill>
-                  <a:srgbClr val="111111"/>
-                </a:solidFill>
-                <a:latin typeface="Aptos"/>
-              </a:rPr>
-              <a:t>G_{r,e}={(t,x_t,α_t,k): e_t,k=e, e∈E_r}</a:t>
-            </a:r>
-          </a:p>
-        </p:txBody>
-      </p:sp>
-      <p:sp>
-        <p:nvSpPr>
-          <p:cNvPr id="28" name="TextBox 27"/>
-          <p:cNvSpPr txBox="1"/>
-          <p:nvPr/>
-        </p:nvSpPr>
-        <p:spPr>
-          <a:xfrm>
-            <a:off x="2889504" y="3310128"/>
-            <a:ext cx="6291072" cy="155448"/>
-          </a:xfrm>
-          <a:prstGeom prst="rect">
-            <a:avLst/>
-          </a:prstGeom>
-          <a:noFill/>
-          <a:ln>
-            <a:noFill/>
-          </a:ln>
-        </p:spPr>
-        <p:txBody>
-          <a:bodyPr wrap="square" lIns="0" rIns="0" tIns="0" bIns="0" anchor="ctr">
-            <a:spAutoFit/>
-          </a:bodyPr>
-          <a:lstStyle/>
-          <a:p>
-            <a:pPr algn="ctr">
-              <a:lnSpc>
-                <a:spcPct val="100000"/>
-              </a:lnSpc>
-              <a:spcBef>
-                <a:spcPts val="0"/>
-              </a:spcBef>
-              <a:spcAft>
-                <a:spcPts val="0"/>
-              </a:spcAft>
-            </a:pPr>
-            <a:r>
-              <a:rPr sz="710" b="0">
-                <a:solidFill>
-                  <a:srgbClr val="555555"/>
-                </a:solidFill>
-                <a:latin typeface="Microsoft YaHei"/>
-              </a:rPr>
-              <a:t>组队不是按 token；每个 token 可进入 K 个专家队伍</a:t>
-            </a:r>
-          </a:p>
-        </p:txBody>
-      </p:sp>
-      <p:sp>
-        <p:nvSpPr>
-          <p:cNvPr id="29" name="Rectangle 28"/>
-          <p:cNvSpPr/>
-          <p:nvPr/>
-        </p:nvSpPr>
-        <p:spPr>
-          <a:xfrm>
-            <a:off x="2743200" y="3703320"/>
-            <a:ext cx="6583680" cy="713232"/>
-          </a:xfrm>
-          <a:prstGeom prst="rect">
-            <a:avLst/>
-          </a:prstGeom>
-          <a:solidFill>
-            <a:srgbClr val="FFFFFF"/>
-          </a:solidFill>
-          <a:ln w="12700">
-            <a:solidFill>
-              <a:srgbClr val="111111"/>
-            </a:solidFill>
-          </a:ln>
-        </p:spPr>
-        <p:style>
-          <a:lnRef idx="1">
-            <a:schemeClr val="accent1"/>
-          </a:lnRef>
-          <a:fillRef idx="3">
-            <a:schemeClr val="accent1"/>
-          </a:fillRef>
-          <a:effectRef idx="2">
-            <a:schemeClr val="accent1"/>
-          </a:effectRef>
-          <a:fontRef idx="minor">
-            <a:schemeClr val="lt1"/>
-          </a:fontRef>
-        </p:style>
-        <p:txBody>
-          <a:bodyPr rtlCol="0" anchor="ctr"/>
-          <a:lstStyle/>
-          <a:p>
-            <a:pPr algn="ctr"/>
-          </a:p>
-        </p:txBody>
-      </p:sp>
-      <p:sp>
-        <p:nvSpPr>
-          <p:cNvPr id="30" name="TextBox 29"/>
-          <p:cNvSpPr txBox="1"/>
-          <p:nvPr/>
-        </p:nvSpPr>
-        <p:spPr>
-          <a:xfrm>
-            <a:off x="2889504" y="3758183"/>
-            <a:ext cx="6291072" cy="182880"/>
-          </a:xfrm>
-          <a:prstGeom prst="rect">
-            <a:avLst/>
-          </a:prstGeom>
-          <a:noFill/>
-          <a:ln>
-            <a:noFill/>
-          </a:ln>
-        </p:spPr>
-        <p:txBody>
-          <a:bodyPr wrap="square" lIns="0" rIns="0" tIns="0" bIns="0" anchor="ctr">
-            <a:spAutoFit/>
-          </a:bodyPr>
-          <a:lstStyle/>
-          <a:p>
-            <a:pPr algn="ctr">
-              <a:lnSpc>
-                <a:spcPct val="100000"/>
-              </a:lnSpc>
-              <a:spcBef>
-                <a:spcPts val="0"/>
-              </a:spcBef>
-              <a:spcAft>
-                <a:spcPts val="0"/>
-              </a:spcAft>
-            </a:pPr>
-            <a:r>
-              <a:rPr sz="969" b="1">
-                <a:solidFill>
-                  <a:srgbClr val="111111"/>
-                </a:solidFill>
-                <a:latin typeface="Microsoft YaHei"/>
-              </a:rPr>
-              <a:t>Token 小队 + 本地 Expert 批量计算</a:t>
-            </a:r>
-          </a:p>
-        </p:txBody>
-      </p:sp>
-      <p:sp>
-        <p:nvSpPr>
-          <p:cNvPr id="31" name="TextBox 30"/>
-          <p:cNvSpPr txBox="1"/>
-          <p:nvPr/>
-        </p:nvSpPr>
-        <p:spPr>
-          <a:xfrm>
-            <a:off x="2889504" y="3959352"/>
-            <a:ext cx="6291072" cy="365760"/>
-          </a:xfrm>
-          <a:prstGeom prst="rect">
-            <a:avLst/>
-          </a:prstGeom>
-          <a:noFill/>
-          <a:ln>
-            <a:noFill/>
-          </a:ln>
-        </p:spPr>
-        <p:txBody>
-          <a:bodyPr wrap="square" lIns="0" rIns="0" tIns="0" bIns="0" anchor="ctr">
-            <a:spAutoFit/>
-          </a:bodyPr>
-          <a:lstStyle/>
-          <a:p>
-            <a:pPr algn="ctr">
-              <a:lnSpc>
-                <a:spcPct val="100000"/>
-              </a:lnSpc>
-              <a:spcBef>
-                <a:spcPts val="0"/>
-              </a:spcBef>
-              <a:spcAft>
-                <a:spcPts val="0"/>
-              </a:spcAft>
-            </a:pPr>
-            <a:r>
-              <a:rPr sz="750" b="1">
-                <a:solidFill>
-                  <a:srgbClr val="111111"/>
-                </a:solidFill>
-                <a:latin typeface="Aptos"/>
-              </a:rPr>
-              <a:t>h_t,e=SiLU(x_t W1^e) ⊙ (x_t W3^e)</a:t>
-            </a:r>
-            <a:br/>
-            <a:r>
-              <a:rPr sz="750" b="1">
-                <a:solidFill>
-                  <a:srgbClr val="111111"/>
-                </a:solidFill>
-                <a:latin typeface="Aptos"/>
-              </a:rPr>
-              <a:t>y_t,e=W2^e(α_t,e · h_t,e)</a:t>
-            </a:r>
-          </a:p>
-        </p:txBody>
-      </p:sp>
-      <p:sp>
-        <p:nvSpPr>
-          <p:cNvPr id="32" name="TextBox 31"/>
-          <p:cNvSpPr txBox="1"/>
-          <p:nvPr/>
-        </p:nvSpPr>
-        <p:spPr>
-          <a:xfrm>
-            <a:off x="2889504" y="4197096"/>
-            <a:ext cx="6291072" cy="155448"/>
-          </a:xfrm>
-          <a:prstGeom prst="rect">
-            <a:avLst/>
-          </a:prstGeom>
-          <a:noFill/>
-          <a:ln>
-            <a:noFill/>
-          </a:ln>
-        </p:spPr>
-        <p:txBody>
-          <a:bodyPr wrap="square" lIns="0" rIns="0" tIns="0" bIns="0" anchor="ctr">
-            <a:spAutoFit/>
-          </a:bodyPr>
-          <a:lstStyle/>
-          <a:p>
-            <a:pPr algn="ctr">
-              <a:lnSpc>
-                <a:spcPct val="100000"/>
-              </a:lnSpc>
-              <a:spcBef>
-                <a:spcPts val="0"/>
-              </a:spcBef>
-              <a:spcAft>
-                <a:spcPts val="0"/>
-              </a:spcAft>
-            </a:pPr>
-            <a:r>
               <a:rPr sz="690" b="0">
-                <a:solidFill>
-                  <a:srgbClr val="555555"/>
-                </a:solidFill>
-                <a:latin typeface="Microsoft YaHei"/>
-              </a:rPr>
-              <a:t>idx,top=where(I==e)；routed=Expert(X[idx], A[idx,top])</a:t>
-            </a:r>
-          </a:p>
-        </p:txBody>
-      </p:sp>
-      <p:sp>
-        <p:nvSpPr>
-          <p:cNvPr id="33" name="Rectangle 32"/>
-          <p:cNvSpPr/>
-          <p:nvPr/>
-        </p:nvSpPr>
-        <p:spPr>
-          <a:xfrm>
-            <a:off x="2743200" y="4599432"/>
-            <a:ext cx="6583680" cy="493776"/>
-          </a:xfrm>
-          <a:prstGeom prst="rect">
-            <a:avLst/>
-          </a:prstGeom>
-          <a:solidFill>
-            <a:srgbClr val="FFFFFF"/>
-          </a:solidFill>
-          <a:ln w="12700">
-            <a:solidFill>
-              <a:srgbClr val="111111"/>
-            </a:solidFill>
-          </a:ln>
-        </p:spPr>
-        <p:style>
-          <a:lnRef idx="1">
-            <a:schemeClr val="accent1"/>
-          </a:lnRef>
-          <a:fillRef idx="3">
-            <a:schemeClr val="accent1"/>
-          </a:fillRef>
-          <a:effectRef idx="2">
-            <a:schemeClr val="accent1"/>
-          </a:effectRef>
-          <a:fontRef idx="minor">
-            <a:schemeClr val="lt1"/>
-          </a:fontRef>
-        </p:style>
-        <p:txBody>
-          <a:bodyPr rtlCol="0" anchor="ctr"/>
-          <a:lstStyle/>
-          <a:p>
-            <a:pPr algn="ctr"/>
-          </a:p>
-        </p:txBody>
-      </p:sp>
-      <p:sp>
-        <p:nvSpPr>
-          <p:cNvPr id="34" name="TextBox 33"/>
-          <p:cNvSpPr txBox="1"/>
-          <p:nvPr/>
-        </p:nvSpPr>
-        <p:spPr>
-          <a:xfrm>
-            <a:off x="2889504" y="4654296"/>
-            <a:ext cx="6291072" cy="182880"/>
-          </a:xfrm>
-          <a:prstGeom prst="rect">
-            <a:avLst/>
-          </a:prstGeom>
-          <a:noFill/>
-          <a:ln>
-            <a:noFill/>
-          </a:ln>
-        </p:spPr>
-        <p:txBody>
-          <a:bodyPr wrap="square" lIns="0" rIns="0" tIns="0" bIns="0" anchor="ctr">
-            <a:spAutoFit/>
-          </a:bodyPr>
-          <a:lstStyle/>
-          <a:p>
-            <a:pPr algn="ctr">
-              <a:lnSpc>
-                <a:spcPct val="100000"/>
-              </a:lnSpc>
-              <a:spcBef>
-                <a:spcPts val="0"/>
-              </a:spcBef>
-              <a:spcAft>
-                <a:spcPts val="0"/>
-              </a:spcAft>
-            </a:pPr>
-            <a:r>
-              <a:rPr sz="969" b="1">
-                <a:solidFill>
-                  <a:srgbClr val="111111"/>
-                </a:solidFill>
-                <a:latin typeface="Microsoft YaHei"/>
-              </a:rPr>
-              <a:t>Token 小队归位：按 token_pos 局部累加</a:t>
-            </a:r>
-          </a:p>
-        </p:txBody>
-      </p:sp>
-      <p:sp>
-        <p:nvSpPr>
-          <p:cNvPr id="35" name="TextBox 34"/>
-          <p:cNvSpPr txBox="1"/>
-          <p:nvPr/>
-        </p:nvSpPr>
-        <p:spPr>
-          <a:xfrm>
-            <a:off x="2889504" y="4855464"/>
-            <a:ext cx="6291072" cy="219456"/>
-          </a:xfrm>
-          <a:prstGeom prst="rect">
-            <a:avLst/>
-          </a:prstGeom>
-          <a:noFill/>
-          <a:ln>
-            <a:noFill/>
-          </a:ln>
-        </p:spPr>
-        <p:txBody>
-          <a:bodyPr wrap="square" lIns="0" rIns="0" tIns="0" bIns="0" anchor="ctr">
-            <a:spAutoFit/>
-          </a:bodyPr>
-          <a:lstStyle/>
-          <a:p>
-            <a:pPr algn="ctr">
-              <a:lnSpc>
-                <a:spcPct val="100000"/>
-              </a:lnSpc>
-              <a:spcBef>
-                <a:spcPts val="0"/>
-              </a:spcBef>
-              <a:spcAft>
-                <a:spcPts val="0"/>
-              </a:spcAft>
-            </a:pPr>
-            <a:r>
-              <a:rPr sz="830" b="1">
-                <a:solidFill>
-                  <a:srgbClr val="111111"/>
-                </a:solidFill>
-                <a:latin typeface="Aptos"/>
-              </a:rPr>
-              <a:t>y_r[t] += y_t,e</a:t>
-            </a:r>
-          </a:p>
-        </p:txBody>
-      </p:sp>
-      <p:sp>
-        <p:nvSpPr>
-          <p:cNvPr id="36" name="TextBox 35"/>
-          <p:cNvSpPr txBox="1"/>
-          <p:nvPr/>
-        </p:nvSpPr>
-        <p:spPr>
-          <a:xfrm>
-            <a:off x="2889504" y="4873752"/>
-            <a:ext cx="6291072" cy="155448"/>
-          </a:xfrm>
-          <a:prstGeom prst="rect">
-            <a:avLst/>
-          </a:prstGeom>
-          <a:noFill/>
-          <a:ln>
-            <a:noFill/>
-          </a:ln>
-        </p:spPr>
-        <p:txBody>
-          <a:bodyPr wrap="square" lIns="0" rIns="0" tIns="0" bIns="0" anchor="ctr">
-            <a:spAutoFit/>
-          </a:bodyPr>
-          <a:lstStyle/>
-          <a:p>
-            <a:pPr algn="ctr">
-              <a:lnSpc>
-                <a:spcPct val="100000"/>
-              </a:lnSpc>
-              <a:spcBef>
-                <a:spcPts val="0"/>
-              </a:spcBef>
-              <a:spcAft>
-                <a:spcPts val="0"/>
-              </a:spcAft>
-            </a:pPr>
-            <a:r>
-              <a:rPr sz="700" b="0">
-                <a:solidFill>
-                  <a:srgbClr val="555555"/>
-                </a:solidFill>
-                <a:latin typeface="Microsoft YaHei"/>
-              </a:rPr>
-              <a:t>local_output.index_add_(0, token_index, routed)</a:t>
-            </a:r>
-          </a:p>
-        </p:txBody>
-      </p:sp>
-      <p:sp>
-        <p:nvSpPr>
-          <p:cNvPr id="37" name="Rectangle 36"/>
-          <p:cNvSpPr/>
-          <p:nvPr/>
-        </p:nvSpPr>
-        <p:spPr>
-          <a:xfrm>
-            <a:off x="2743200" y="5257800"/>
-            <a:ext cx="6583680" cy="493776"/>
-          </a:xfrm>
-          <a:prstGeom prst="rect">
-            <a:avLst/>
-          </a:prstGeom>
-          <a:solidFill>
-            <a:srgbClr val="FFFFFF"/>
-          </a:solidFill>
-          <a:ln w="12700">
-            <a:solidFill>
-              <a:srgbClr val="111111"/>
-            </a:solidFill>
-          </a:ln>
-        </p:spPr>
-        <p:style>
-          <a:lnRef idx="1">
-            <a:schemeClr val="accent1"/>
-          </a:lnRef>
-          <a:fillRef idx="3">
-            <a:schemeClr val="accent1"/>
-          </a:fillRef>
-          <a:effectRef idx="2">
-            <a:schemeClr val="accent1"/>
-          </a:effectRef>
-          <a:fontRef idx="minor">
-            <a:schemeClr val="lt1"/>
-          </a:fontRef>
-        </p:style>
-        <p:txBody>
-          <a:bodyPr rtlCol="0" anchor="ctr"/>
-          <a:lstStyle/>
-          <a:p>
-            <a:pPr algn="ctr"/>
-          </a:p>
-        </p:txBody>
-      </p:sp>
-      <p:sp>
-        <p:nvSpPr>
-          <p:cNvPr id="38" name="TextBox 37"/>
-          <p:cNvSpPr txBox="1"/>
-          <p:nvPr/>
-        </p:nvSpPr>
-        <p:spPr>
-          <a:xfrm>
-            <a:off x="2889504" y="5312664"/>
-            <a:ext cx="6291072" cy="182880"/>
-          </a:xfrm>
-          <a:prstGeom prst="rect">
-            <a:avLst/>
-          </a:prstGeom>
-          <a:noFill/>
-          <a:ln>
-            <a:noFill/>
-          </a:ln>
-        </p:spPr>
-        <p:txBody>
-          <a:bodyPr wrap="square" lIns="0" rIns="0" tIns="0" bIns="0" anchor="ctr">
-            <a:spAutoFit/>
-          </a:bodyPr>
-          <a:lstStyle/>
-          <a:p>
-            <a:pPr algn="ctr">
-              <a:lnSpc>
-                <a:spcPct val="100000"/>
-              </a:lnSpc>
-              <a:spcBef>
-                <a:spcPts val="0"/>
-              </a:spcBef>
-              <a:spcAft>
-                <a:spcPts val="0"/>
-              </a:spcAft>
-            </a:pPr>
-            <a:r>
-              <a:rPr sz="969" b="1">
-                <a:solidFill>
-                  <a:srgbClr val="111111"/>
-                </a:solidFill>
-                <a:latin typeface="Microsoft YaHei"/>
-              </a:rPr>
-              <a:t>所有 core 对 routed 结果做 AllReduce(sum)</a:t>
-            </a:r>
-          </a:p>
-        </p:txBody>
-      </p:sp>
-      <p:sp>
-        <p:nvSpPr>
-          <p:cNvPr id="39" name="TextBox 38"/>
-          <p:cNvSpPr txBox="1"/>
-          <p:nvPr/>
-        </p:nvSpPr>
-        <p:spPr>
-          <a:xfrm>
-            <a:off x="2889504" y="5513832"/>
-            <a:ext cx="6291072" cy="219456"/>
-          </a:xfrm>
-          <a:prstGeom prst="rect">
-            <a:avLst/>
-          </a:prstGeom>
-          <a:noFill/>
-          <a:ln>
-            <a:noFill/>
-          </a:ln>
-        </p:spPr>
-        <p:txBody>
-          <a:bodyPr wrap="square" lIns="0" rIns="0" tIns="0" bIns="0" anchor="ctr">
-            <a:spAutoFit/>
-          </a:bodyPr>
-          <a:lstStyle/>
-          <a:p>
-            <a:pPr algn="ctr">
-              <a:lnSpc>
-                <a:spcPct val="100000"/>
-              </a:lnSpc>
-              <a:spcBef>
-                <a:spcPts val="0"/>
-              </a:spcBef>
-              <a:spcAft>
-                <a:spcPts val="0"/>
-              </a:spcAft>
-            </a:pPr>
-            <a:r>
-              <a:rPr sz="830" b="1">
-                <a:solidFill>
-                  <a:srgbClr val="111111"/>
-                </a:solidFill>
-                <a:latin typeface="Aptos"/>
-              </a:rPr>
-              <a:t>y_routed[t] = Σ_r y_r[t]</a:t>
-            </a:r>
-          </a:p>
-        </p:txBody>
-      </p:sp>
-      <p:sp>
-        <p:nvSpPr>
-          <p:cNvPr id="40" name="TextBox 39"/>
-          <p:cNvSpPr txBox="1"/>
-          <p:nvPr/>
-        </p:nvSpPr>
-        <p:spPr>
-          <a:xfrm>
-            <a:off x="2889504" y="5532120"/>
-            <a:ext cx="6291072" cy="155448"/>
-          </a:xfrm>
-          <a:prstGeom prst="rect">
-            <a:avLst/>
-          </a:prstGeom>
-          <a:noFill/>
-          <a:ln>
-            <a:noFill/>
-          </a:ln>
-        </p:spPr>
-        <p:txBody>
-          <a:bodyPr wrap="square" lIns="0" rIns="0" tIns="0" bIns="0" anchor="ctr">
-            <a:spAutoFit/>
-          </a:bodyPr>
-          <a:lstStyle/>
-          <a:p>
-            <a:pPr algn="ctr">
-              <a:lnSpc>
-                <a:spcPct val="100000"/>
-              </a:lnSpc>
-              <a:spcBef>
-                <a:spcPts val="0"/>
-              </a:spcBef>
-              <a:spcAft>
-                <a:spcPts val="0"/>
-              </a:spcAft>
-            </a:pPr>
-            <a:r>
-              <a:rPr sz="700" b="0">
-                <a:solidFill>
-                  <a:srgbClr val="555555"/>
-                </a:solidFill>
-                <a:latin typeface="Microsoft YaHei"/>
-              </a:rPr>
-              <a:t>逐 token、逐维求和；shared 不参与此归约</a:t>
-            </a:r>
-          </a:p>
-        </p:txBody>
-      </p:sp>
-      <p:sp>
-        <p:nvSpPr>
-          <p:cNvPr id="41" name="Rectangle 40"/>
-          <p:cNvSpPr/>
-          <p:nvPr/>
-        </p:nvSpPr>
-        <p:spPr>
-          <a:xfrm>
-            <a:off x="2743200" y="5916168"/>
-            <a:ext cx="6583680" cy="512064"/>
-          </a:xfrm>
-          <a:prstGeom prst="rect">
-            <a:avLst/>
-          </a:prstGeom>
-          <a:solidFill>
-            <a:srgbClr val="FFFFFF"/>
-          </a:solidFill>
-          <a:ln w="12700">
-            <a:solidFill>
-              <a:srgbClr val="111111"/>
-            </a:solidFill>
-          </a:ln>
-        </p:spPr>
-        <p:style>
-          <a:lnRef idx="1">
-            <a:schemeClr val="accent1"/>
-          </a:lnRef>
-          <a:fillRef idx="3">
-            <a:schemeClr val="accent1"/>
-          </a:fillRef>
-          <a:effectRef idx="2">
-            <a:schemeClr val="accent1"/>
-          </a:effectRef>
-          <a:fontRef idx="minor">
-            <a:schemeClr val="lt1"/>
-          </a:fontRef>
-        </p:style>
-        <p:txBody>
-          <a:bodyPr rtlCol="0" anchor="ctr"/>
-          <a:lstStyle/>
-          <a:p>
-            <a:pPr algn="ctr"/>
-          </a:p>
-        </p:txBody>
-      </p:sp>
-      <p:sp>
-        <p:nvSpPr>
-          <p:cNvPr id="42" name="TextBox 41"/>
-          <p:cNvSpPr txBox="1"/>
-          <p:nvPr/>
-        </p:nvSpPr>
-        <p:spPr>
-          <a:xfrm>
-            <a:off x="2889504" y="5971031"/>
-            <a:ext cx="6291072" cy="182880"/>
-          </a:xfrm>
-          <a:prstGeom prst="rect">
-            <a:avLst/>
-          </a:prstGeom>
-          <a:noFill/>
-          <a:ln>
-            <a:noFill/>
-          </a:ln>
-        </p:spPr>
-        <p:txBody>
-          <a:bodyPr wrap="square" lIns="0" rIns="0" tIns="0" bIns="0" anchor="ctr">
-            <a:spAutoFit/>
-          </a:bodyPr>
-          <a:lstStyle/>
-          <a:p>
-            <a:pPr algn="ctr">
-              <a:lnSpc>
-                <a:spcPct val="100000"/>
-              </a:lnSpc>
-              <a:spcBef>
-                <a:spcPts val="0"/>
-              </a:spcBef>
-              <a:spcAft>
-                <a:spcPts val="0"/>
-              </a:spcAft>
-            </a:pPr>
-            <a:r>
-              <a:rPr sz="1000" b="1">
-                <a:solidFill>
-                  <a:srgbClr val="111111"/>
-                </a:solidFill>
-                <a:latin typeface="Microsoft YaHei"/>
-              </a:rPr>
-              <a:t>最终输出</a:t>
-            </a:r>
-          </a:p>
-        </p:txBody>
-      </p:sp>
-      <p:sp>
-        <p:nvSpPr>
-          <p:cNvPr id="43" name="TextBox 42"/>
-          <p:cNvSpPr txBox="1"/>
-          <p:nvPr/>
-        </p:nvSpPr>
-        <p:spPr>
-          <a:xfrm>
-            <a:off x="2889504" y="6172200"/>
-            <a:ext cx="6291072" cy="219456"/>
-          </a:xfrm>
-          <a:prstGeom prst="rect">
-            <a:avLst/>
-          </a:prstGeom>
-          <a:noFill/>
-          <a:ln>
-            <a:noFill/>
-          </a:ln>
-        </p:spPr>
-        <p:txBody>
-          <a:bodyPr wrap="square" lIns="0" rIns="0" tIns="0" bIns="0" anchor="ctr">
-            <a:spAutoFit/>
-          </a:bodyPr>
-          <a:lstStyle/>
-          <a:p>
-            <a:pPr algn="ctr">
-              <a:lnSpc>
-                <a:spcPct val="100000"/>
-              </a:lnSpc>
-              <a:spcBef>
-                <a:spcPts val="0"/>
-              </a:spcBef>
-              <a:spcAft>
-                <a:spcPts val="0"/>
-              </a:spcAft>
-            </a:pPr>
-            <a:r>
-              <a:rPr sz="869" b="1">
-                <a:solidFill>
-                  <a:srgbClr val="111111"/>
-                </a:solidFill>
-                <a:latin typeface="Aptos"/>
-              </a:rPr>
-              <a:t>y[t] = y_routed[t] + y_shared[t]</a:t>
-            </a:r>
-          </a:p>
-        </p:txBody>
-      </p:sp>
-      <p:sp>
-        <p:nvSpPr>
-          <p:cNvPr id="44" name="TextBox 43"/>
-          <p:cNvSpPr txBox="1"/>
-          <p:nvPr/>
-        </p:nvSpPr>
-        <p:spPr>
-          <a:xfrm>
-            <a:off x="2889504" y="6208775"/>
-            <a:ext cx="6291072" cy="155448"/>
-          </a:xfrm>
-          <a:prstGeom prst="rect">
-            <a:avLst/>
-          </a:prstGeom>
-          <a:noFill/>
-          <a:ln>
-            <a:noFill/>
-          </a:ln>
-        </p:spPr>
-        <p:txBody>
-          <a:bodyPr wrap="square" lIns="0" rIns="0" tIns="0" bIns="0" anchor="ctr">
-            <a:spAutoFit/>
-          </a:bodyPr>
-          <a:lstStyle/>
-          <a:p>
-            <a:pPr algn="ctr">
-              <a:lnSpc>
-                <a:spcPct val="100000"/>
-              </a:lnSpc>
-              <a:spcBef>
-                <a:spcPts val="0"/>
-              </a:spcBef>
-              <a:spcAft>
-                <a:spcPts val="0"/>
-              </a:spcAft>
-            </a:pPr>
-            <a:r>
-              <a:rPr sz="710" b="0">
-                <a:solidFill>
-                  <a:srgbClr val="555555"/>
-                </a:solidFill>
-                <a:latin typeface="Microsoft YaHei"/>
-              </a:rPr>
-              <a:t>[T,D] → [B,S,D] → HC post</a:t>
-            </a:r>
-          </a:p>
-        </p:txBody>
-      </p:sp>
-      <p:sp>
-        <p:nvSpPr>
-          <p:cNvPr id="45" name="Rectangle 44"/>
-          <p:cNvSpPr/>
-          <p:nvPr/>
-        </p:nvSpPr>
-        <p:spPr>
-          <a:xfrm>
-            <a:off x="9646920" y="4498848"/>
-            <a:ext cx="2057400" cy="713232"/>
-          </a:xfrm>
-          <a:prstGeom prst="rect">
-            <a:avLst/>
-          </a:prstGeom>
-          <a:solidFill>
-            <a:srgbClr val="FFFFFF"/>
-          </a:solidFill>
-          <a:ln w="12700">
-            <a:solidFill>
-              <a:srgbClr val="111111"/>
-            </a:solidFill>
-          </a:ln>
-        </p:spPr>
-        <p:style>
-          <a:lnRef idx="1">
-            <a:schemeClr val="accent1"/>
-          </a:lnRef>
-          <a:fillRef idx="3">
-            <a:schemeClr val="accent1"/>
-          </a:fillRef>
-          <a:effectRef idx="2">
-            <a:schemeClr val="accent1"/>
-          </a:effectRef>
-          <a:fontRef idx="minor">
-            <a:schemeClr val="lt1"/>
-          </a:fontRef>
-        </p:style>
-        <p:txBody>
-          <a:bodyPr rtlCol="0" anchor="ctr"/>
-          <a:lstStyle/>
-          <a:p>
-            <a:pPr algn="ctr"/>
-          </a:p>
-        </p:txBody>
-      </p:sp>
-      <p:sp>
-        <p:nvSpPr>
-          <p:cNvPr id="46" name="TextBox 45"/>
-          <p:cNvSpPr txBox="1"/>
-          <p:nvPr/>
-        </p:nvSpPr>
-        <p:spPr>
-          <a:xfrm>
-            <a:off x="9793224" y="4553712"/>
-            <a:ext cx="1764792" cy="182880"/>
-          </a:xfrm>
-          <a:prstGeom prst="rect">
-            <a:avLst/>
-          </a:prstGeom>
-          <a:noFill/>
-          <a:ln>
-            <a:noFill/>
-          </a:ln>
-        </p:spPr>
-        <p:txBody>
-          <a:bodyPr wrap="square" lIns="0" rIns="0" tIns="0" bIns="0" anchor="ctr">
-            <a:spAutoFit/>
-          </a:bodyPr>
-          <a:lstStyle/>
-          <a:p>
-            <a:pPr algn="ctr">
-              <a:lnSpc>
-                <a:spcPct val="100000"/>
-              </a:lnSpc>
-              <a:spcBef>
-                <a:spcPts val="0"/>
-              </a:spcBef>
-              <a:spcAft>
-                <a:spcPts val="0"/>
-              </a:spcAft>
-            </a:pPr>
-            <a:r>
-              <a:rPr sz="900" b="1">
-                <a:solidFill>
-                  <a:srgbClr val="111111"/>
-                </a:solidFill>
-                <a:latin typeface="Microsoft YaHei"/>
-              </a:rPr>
-              <a:t>Shared Expert（always on）</a:t>
-            </a:r>
-          </a:p>
-        </p:txBody>
-      </p:sp>
-      <p:sp>
-        <p:nvSpPr>
-          <p:cNvPr id="47" name="TextBox 46"/>
-          <p:cNvSpPr txBox="1"/>
-          <p:nvPr/>
-        </p:nvSpPr>
-        <p:spPr>
-          <a:xfrm>
-            <a:off x="9793224" y="4754880"/>
-            <a:ext cx="1764792" cy="219456"/>
-          </a:xfrm>
-          <a:prstGeom prst="rect">
-            <a:avLst/>
-          </a:prstGeom>
-          <a:noFill/>
-          <a:ln>
-            <a:noFill/>
-          </a:ln>
-        </p:spPr>
-        <p:txBody>
-          <a:bodyPr wrap="square" lIns="0" rIns="0" tIns="0" bIns="0" anchor="ctr">
-            <a:spAutoFit/>
-          </a:bodyPr>
-          <a:lstStyle/>
-          <a:p>
-            <a:pPr algn="ctr">
-              <a:lnSpc>
-                <a:spcPct val="100000"/>
-              </a:lnSpc>
-              <a:spcBef>
-                <a:spcPts val="0"/>
-              </a:spcBef>
-              <a:spcAft>
-                <a:spcPts val="0"/>
-              </a:spcAft>
-            </a:pPr>
-            <a:r>
-              <a:rPr sz="800" b="1">
-                <a:solidFill>
-                  <a:srgbClr val="111111"/>
-                </a:solidFill>
-                <a:latin typeface="Aptos"/>
-              </a:rPr>
-              <a:t>y_shared[t] = S(x_t)</a:t>
-            </a:r>
-          </a:p>
-        </p:txBody>
-      </p:sp>
-      <p:sp>
-        <p:nvSpPr>
-          <p:cNvPr id="48" name="TextBox 47"/>
-          <p:cNvSpPr txBox="1"/>
-          <p:nvPr/>
-        </p:nvSpPr>
-        <p:spPr>
-          <a:xfrm>
-            <a:off x="9793224" y="4992624"/>
-            <a:ext cx="1764792" cy="155448"/>
-          </a:xfrm>
-          <a:prstGeom prst="rect">
-            <a:avLst/>
-          </a:prstGeom>
-          <a:noFill/>
-          <a:ln>
-            <a:noFill/>
-          </a:ln>
-        </p:spPr>
-        <p:txBody>
-          <a:bodyPr wrap="square" lIns="0" rIns="0" tIns="0" bIns="0" anchor="ctr">
-            <a:spAutoFit/>
-          </a:bodyPr>
-          <a:lstStyle/>
-          <a:p>
-            <a:pPr algn="ctr">
-              <a:lnSpc>
-                <a:spcPct val="100000"/>
-              </a:lnSpc>
-              <a:spcBef>
-                <a:spcPts val="0"/>
-              </a:spcBef>
-              <a:spcAft>
-                <a:spcPts val="0"/>
-              </a:spcAft>
-            </a:pPr>
-            <a:r>
-              <a:rPr sz="680" b="0">
                 <a:solidFill>
                   <a:srgbClr val="555555"/>
                 </a:solidFill>
@@ -5326,19 +4789,19 @@
       </p:sp>
       <p:cxnSp>
         <p:nvCxnSpPr>
-          <p:cNvPr id="49" name="Connector 48"/>
+          <p:cNvPr id="25" name="Connector 24"/>
           <p:cNvCxnSpPr/>
           <p:nvPr/>
         </p:nvCxnSpPr>
         <p:spPr>
           <a:xfrm>
-            <a:off x="6035040" y="1453896"/>
-            <a:ext cx="0" cy="54864"/>
+            <a:off x="4782312" y="1316736"/>
+            <a:ext cx="0" cy="146303"/>
           </a:xfrm>
           <a:prstGeom prst="line">
             <a:avLst/>
           </a:prstGeom>
-          <a:ln w="13970">
+          <a:ln w="12700">
             <a:solidFill>
               <a:srgbClr val="111111"/>
             </a:solidFill>
@@ -5361,14 +4824,14 @@
       </p:cxnSp>
       <p:sp>
         <p:nvSpPr>
-          <p:cNvPr id="50" name="Down Arrow 49"/>
+          <p:cNvPr id="26" name="Down Arrow 25"/>
           <p:cNvSpPr/>
           <p:nvPr/>
         </p:nvSpPr>
         <p:spPr>
           <a:xfrm>
-            <a:off x="5961888" y="1453896"/>
-            <a:ext cx="146304" cy="146304"/>
+            <a:off x="4727448" y="1426463"/>
+            <a:ext cx="109728" cy="91440"/>
           </a:xfrm>
           <a:prstGeom prst="downArrow">
             <a:avLst/>
@@ -5404,19 +4867,19 @@
       </p:sp>
       <p:cxnSp>
         <p:nvCxnSpPr>
-          <p:cNvPr id="51" name="Connector 50"/>
+          <p:cNvPr id="27" name="Connector 26"/>
           <p:cNvCxnSpPr/>
           <p:nvPr/>
         </p:nvCxnSpPr>
         <p:spPr>
           <a:xfrm>
-            <a:off x="6035040" y="2093976"/>
-            <a:ext cx="0" cy="73152"/>
+            <a:off x="4782312" y="2029968"/>
+            <a:ext cx="0" cy="91440"/>
           </a:xfrm>
           <a:prstGeom prst="line">
             <a:avLst/>
           </a:prstGeom>
-          <a:ln w="13970">
+          <a:ln w="12700">
             <a:solidFill>
               <a:srgbClr val="111111"/>
             </a:solidFill>
@@ -5439,14 +4902,14 @@
       </p:cxnSp>
       <p:sp>
         <p:nvSpPr>
-          <p:cNvPr id="52" name="Down Arrow 51"/>
+          <p:cNvPr id="28" name="Down Arrow 27"/>
           <p:cNvSpPr/>
           <p:nvPr/>
         </p:nvSpPr>
         <p:spPr>
           <a:xfrm>
-            <a:off x="5961888" y="2112264"/>
-            <a:ext cx="146304" cy="146304"/>
+            <a:off x="4727448" y="2084831"/>
+            <a:ext cx="109728" cy="91440"/>
           </a:xfrm>
           <a:prstGeom prst="downArrow">
             <a:avLst/>
@@ -5482,19 +4945,19 @@
       </p:sp>
       <p:cxnSp>
         <p:nvCxnSpPr>
-          <p:cNvPr id="53" name="Connector 52"/>
+          <p:cNvPr id="29" name="Connector 28"/>
           <p:cNvCxnSpPr/>
           <p:nvPr/>
         </p:nvCxnSpPr>
         <p:spPr>
           <a:xfrm>
-            <a:off x="6035040" y="2752344"/>
-            <a:ext cx="0" cy="73152"/>
+            <a:off x="4782312" y="2688336"/>
+            <a:ext cx="0" cy="91440"/>
           </a:xfrm>
           <a:prstGeom prst="line">
             <a:avLst/>
           </a:prstGeom>
-          <a:ln w="13970">
+          <a:ln w="12700">
             <a:solidFill>
               <a:srgbClr val="111111"/>
             </a:solidFill>
@@ -5517,14 +4980,14 @@
       </p:cxnSp>
       <p:sp>
         <p:nvSpPr>
-          <p:cNvPr id="54" name="Down Arrow 53"/>
+          <p:cNvPr id="30" name="Down Arrow 29"/>
           <p:cNvSpPr/>
           <p:nvPr/>
         </p:nvSpPr>
         <p:spPr>
           <a:xfrm>
-            <a:off x="5961888" y="2770632"/>
-            <a:ext cx="146304" cy="146304"/>
+            <a:off x="4727448" y="2743200"/>
+            <a:ext cx="109728" cy="91440"/>
           </a:xfrm>
           <a:prstGeom prst="downArrow">
             <a:avLst/>
@@ -5560,19 +5023,19 @@
       </p:sp>
       <p:cxnSp>
         <p:nvCxnSpPr>
-          <p:cNvPr id="55" name="Connector 54"/>
+          <p:cNvPr id="31" name="Connector 30"/>
           <p:cNvCxnSpPr/>
           <p:nvPr/>
         </p:nvCxnSpPr>
         <p:spPr>
           <a:xfrm>
-            <a:off x="6035040" y="3529584"/>
-            <a:ext cx="0" cy="82295"/>
+            <a:off x="4782312" y="3346704"/>
+            <a:ext cx="0" cy="91440"/>
           </a:xfrm>
           <a:prstGeom prst="line">
             <a:avLst/>
           </a:prstGeom>
-          <a:ln w="13970">
+          <a:ln w="12700">
             <a:solidFill>
               <a:srgbClr val="111111"/>
             </a:solidFill>
@@ -5595,14 +5058,14 @@
       </p:cxnSp>
       <p:sp>
         <p:nvSpPr>
-          <p:cNvPr id="56" name="Down Arrow 55"/>
+          <p:cNvPr id="32" name="Down Arrow 31"/>
           <p:cNvSpPr/>
           <p:nvPr/>
         </p:nvSpPr>
         <p:spPr>
           <a:xfrm>
-            <a:off x="5961888" y="3557015"/>
-            <a:ext cx="146304" cy="146304"/>
+            <a:off x="4727448" y="3401568"/>
+            <a:ext cx="109728" cy="91440"/>
           </a:xfrm>
           <a:prstGeom prst="downArrow">
             <a:avLst/>
@@ -5638,19 +5101,19 @@
       </p:sp>
       <p:cxnSp>
         <p:nvCxnSpPr>
-          <p:cNvPr id="57" name="Connector 56"/>
+          <p:cNvPr id="33" name="Connector 32"/>
           <p:cNvCxnSpPr/>
           <p:nvPr/>
         </p:nvCxnSpPr>
         <p:spPr>
           <a:xfrm>
-            <a:off x="6035040" y="4416552"/>
-            <a:ext cx="0" cy="91440"/>
+            <a:off x="4782312" y="4133087"/>
+            <a:ext cx="0" cy="164593"/>
           </a:xfrm>
           <a:prstGeom prst="line">
             <a:avLst/>
           </a:prstGeom>
-          <a:ln w="13970">
+          <a:ln w="12700">
             <a:solidFill>
               <a:srgbClr val="111111"/>
             </a:solidFill>
@@ -5673,14 +5136,14 @@
       </p:cxnSp>
       <p:sp>
         <p:nvSpPr>
-          <p:cNvPr id="58" name="Down Arrow 57"/>
+          <p:cNvPr id="34" name="Down Arrow 33"/>
           <p:cNvSpPr/>
           <p:nvPr/>
         </p:nvSpPr>
         <p:spPr>
           <a:xfrm>
-            <a:off x="5961888" y="4453128"/>
-            <a:ext cx="146304" cy="146304"/>
+            <a:off x="4727448" y="4261104"/>
+            <a:ext cx="109728" cy="91440"/>
           </a:xfrm>
           <a:prstGeom prst="downArrow">
             <a:avLst/>
@@ -5716,19 +5179,19 @@
       </p:sp>
       <p:cxnSp>
         <p:nvCxnSpPr>
-          <p:cNvPr id="59" name="Connector 58"/>
+          <p:cNvPr id="35" name="Connector 34"/>
           <p:cNvCxnSpPr/>
           <p:nvPr/>
         </p:nvCxnSpPr>
         <p:spPr>
           <a:xfrm>
-            <a:off x="6035040" y="5093208"/>
-            <a:ext cx="0" cy="73152"/>
+            <a:off x="4782312" y="4919472"/>
+            <a:ext cx="0" cy="36576"/>
           </a:xfrm>
           <a:prstGeom prst="line">
             <a:avLst/>
           </a:prstGeom>
-          <a:ln w="13970">
+          <a:ln w="12700">
             <a:solidFill>
               <a:srgbClr val="111111"/>
             </a:solidFill>
@@ -5751,14 +5214,14 @@
       </p:cxnSp>
       <p:sp>
         <p:nvSpPr>
-          <p:cNvPr id="60" name="Down Arrow 59"/>
+          <p:cNvPr id="36" name="Down Arrow 35"/>
           <p:cNvSpPr/>
           <p:nvPr/>
         </p:nvSpPr>
         <p:spPr>
           <a:xfrm>
-            <a:off x="5961888" y="5111496"/>
-            <a:ext cx="146304" cy="146304"/>
+            <a:off x="4727448" y="4919472"/>
+            <a:ext cx="109728" cy="91440"/>
           </a:xfrm>
           <a:prstGeom prst="downArrow">
             <a:avLst/>
@@ -5794,19 +5257,19 @@
       </p:sp>
       <p:cxnSp>
         <p:nvCxnSpPr>
-          <p:cNvPr id="61" name="Connector 60"/>
+          <p:cNvPr id="37" name="Connector 36"/>
           <p:cNvCxnSpPr/>
           <p:nvPr/>
         </p:nvCxnSpPr>
         <p:spPr>
           <a:xfrm>
-            <a:off x="6035040" y="5751576"/>
-            <a:ext cx="0" cy="73152"/>
+            <a:off x="4782312" y="5577840"/>
+            <a:ext cx="0" cy="36576"/>
           </a:xfrm>
           <a:prstGeom prst="line">
             <a:avLst/>
           </a:prstGeom>
-          <a:ln w="13970">
+          <a:ln w="12700">
             <a:solidFill>
               <a:srgbClr val="111111"/>
             </a:solidFill>
@@ -5829,14 +5292,14 @@
       </p:cxnSp>
       <p:sp>
         <p:nvSpPr>
-          <p:cNvPr id="62" name="Down Arrow 61"/>
+          <p:cNvPr id="38" name="Down Arrow 37"/>
           <p:cNvSpPr/>
           <p:nvPr/>
         </p:nvSpPr>
         <p:spPr>
           <a:xfrm>
-            <a:off x="5961888" y="5769864"/>
-            <a:ext cx="146304" cy="146304"/>
+            <a:off x="4727448" y="5577840"/>
+            <a:ext cx="109728" cy="91440"/>
           </a:xfrm>
           <a:prstGeom prst="downArrow">
             <a:avLst/>
@@ -5872,14 +5335,14 @@
       </p:sp>
       <p:cxnSp>
         <p:nvCxnSpPr>
-          <p:cNvPr id="63" name="Connector 62"/>
+          <p:cNvPr id="39" name="Connector 38"/>
           <p:cNvCxnSpPr/>
           <p:nvPr/>
         </p:nvCxnSpPr>
         <p:spPr>
           <a:xfrm>
-            <a:off x="1536192" y="1453896"/>
-            <a:ext cx="2167128" cy="146304"/>
+            <a:off x="1307592" y="1316736"/>
+            <a:ext cx="841248" cy="164592"/>
           </a:xfrm>
           <a:prstGeom prst="line">
             <a:avLst/>
@@ -5907,14 +5370,14 @@
       </p:cxnSp>
       <p:cxnSp>
         <p:nvCxnSpPr>
-          <p:cNvPr id="64" name="Connector 63"/>
+          <p:cNvPr id="40" name="Connector 39"/>
           <p:cNvCxnSpPr/>
           <p:nvPr/>
         </p:nvCxnSpPr>
         <p:spPr>
           <a:xfrm flipH="1">
-            <a:off x="8366760" y="1453896"/>
-            <a:ext cx="2304288" cy="146304"/>
+            <a:off x="7589520" y="1316736"/>
+            <a:ext cx="3282696" cy="164592"/>
           </a:xfrm>
           <a:prstGeom prst="line">
             <a:avLst/>
@@ -5942,14 +5405,14 @@
       </p:cxnSp>
       <p:cxnSp>
         <p:nvCxnSpPr>
-          <p:cNvPr id="65" name="Connector 64"/>
+          <p:cNvPr id="41" name="Connector 40"/>
           <p:cNvCxnSpPr/>
           <p:nvPr/>
         </p:nvCxnSpPr>
         <p:spPr>
           <a:xfrm>
-            <a:off x="9326880" y="2505456"/>
-            <a:ext cx="1344168" cy="1993392"/>
+            <a:off x="8851392" y="2999232"/>
+            <a:ext cx="310896" cy="0"/>
           </a:xfrm>
           <a:prstGeom prst="line">
             <a:avLst/>
@@ -5978,14 +5441,14 @@
       </p:cxnSp>
       <p:cxnSp>
         <p:nvCxnSpPr>
-          <p:cNvPr id="66" name="Connector 65"/>
+          <p:cNvPr id="42" name="Connector 41"/>
           <p:cNvCxnSpPr/>
           <p:nvPr/>
         </p:nvCxnSpPr>
         <p:spPr>
-          <a:xfrm>
-            <a:off x="10671048" y="5212080"/>
-            <a:ext cx="0" cy="548640"/>
+          <a:xfrm flipH="1">
+            <a:off x="8851392" y="5056632"/>
+            <a:ext cx="310896" cy="713232"/>
           </a:xfrm>
           <a:prstGeom prst="line">
             <a:avLst/>
@@ -6012,42 +5475,145 @@
           </a:fontRef>
         </p:style>
       </p:cxnSp>
-      <p:cxnSp>
-        <p:nvCxnSpPr>
-          <p:cNvPr id="67" name="Connector 66"/>
-          <p:cNvCxnSpPr/>
+      <p:sp>
+        <p:nvSpPr>
+          <p:cNvPr id="43" name="Left Arrow 42"/>
+          <p:cNvSpPr/>
           <p:nvPr/>
-        </p:nvCxnSpPr>
-        <p:spPr>
-          <a:xfrm flipH="1">
-            <a:off x="9326880" y="5760720"/>
-            <a:ext cx="1344168" cy="411480"/>
-          </a:xfrm>
-          <a:prstGeom prst="line">
+        </p:nvSpPr>
+        <p:spPr>
+          <a:xfrm>
+            <a:off x="8778240" y="5696712"/>
+            <a:ext cx="164592" cy="164592"/>
+          </a:xfrm>
+          <a:prstGeom prst="leftArrow">
             <a:avLst/>
           </a:prstGeom>
-          <a:ln w="12700">
-            <a:solidFill>
-              <a:srgbClr val="111111"/>
-            </a:solidFill>
-            <a:prstDash val="dash"/>
+          <a:solidFill>
+            <a:srgbClr val="111111"/>
+          </a:solidFill>
+          <a:ln>
+            <a:noFill/>
           </a:ln>
         </p:spPr>
         <p:style>
-          <a:lnRef idx="2">
+          <a:lnRef idx="1">
             <a:schemeClr val="accent1"/>
           </a:lnRef>
-          <a:fillRef idx="0">
+          <a:fillRef idx="3">
             <a:schemeClr val="accent1"/>
           </a:fillRef>
-          <a:effectRef idx="1">
+          <a:effectRef idx="2">
             <a:schemeClr val="accent1"/>
           </a:effectRef>
           <a:fontRef idx="minor">
-            <a:schemeClr val="tx1"/>
+            <a:schemeClr val="lt1"/>
           </a:fontRef>
         </p:style>
-      </p:cxnSp>
+        <p:txBody>
+          <a:bodyPr rtlCol="0" anchor="ctr"/>
+          <a:lstStyle/>
+          <a:p>
+            <a:pPr algn="ctr"/>
+          </a:p>
+        </p:txBody>
+      </p:sp>
+      <p:sp>
+        <p:nvSpPr>
+          <p:cNvPr id="44" name="TextBox 43"/>
+          <p:cNvSpPr txBox="1"/>
+          <p:nvPr/>
+        </p:nvSpPr>
+        <p:spPr>
+          <a:xfrm>
+            <a:off x="457200" y="6547104"/>
+            <a:ext cx="8778240" cy="155448"/>
+          </a:xfrm>
+          <a:prstGeom prst="rect">
+            <a:avLst/>
+          </a:prstGeom>
+          <a:noFill/>
+          <a:ln>
+            <a:noFill/>
+          </a:ln>
+        </p:spPr>
+        <p:txBody>
+          <a:bodyPr wrap="square" lIns="0" rIns="0" tIns="0" bIns="0" anchor="ctr">
+            <a:spAutoFit/>
+          </a:bodyPr>
+          <a:lstStyle/>
+          <a:p>
+            <a:pPr algn="l">
+              <a:lnSpc>
+                <a:spcPct val="100000"/>
+              </a:lnSpc>
+              <a:spcBef>
+                <a:spcPts val="0"/>
+              </a:spcBef>
+              <a:spcAft>
+                <a:spcPts val="0"/>
+              </a:spcAft>
+            </a:pPr>
+            <a:r>
+              <a:rPr sz="760" b="0">
+                <a:solidFill>
+                  <a:srgbClr val="555555"/>
+                </a:solidFill>
+                <a:latin typeface="Microsoft YaHei"/>
+              </a:rPr>
+              <a:t>主流程：每一步只保留一个方框；公式与实现说明放在框外，需要时再查看</a:t>
+            </a:r>
+          </a:p>
+        </p:txBody>
+      </p:sp>
+      <p:sp>
+        <p:nvSpPr>
+          <p:cNvPr id="45" name="TextBox 44"/>
+          <p:cNvSpPr txBox="1"/>
+          <p:nvPr/>
+        </p:nvSpPr>
+        <p:spPr>
+          <a:xfrm>
+            <a:off x="9162288" y="6547104"/>
+            <a:ext cx="2670048" cy="155448"/>
+          </a:xfrm>
+          <a:prstGeom prst="rect">
+            <a:avLst/>
+          </a:prstGeom>
+          <a:noFill/>
+          <a:ln>
+            <a:noFill/>
+          </a:ln>
+        </p:spPr>
+        <p:txBody>
+          <a:bodyPr wrap="square" lIns="0" rIns="0" tIns="0" bIns="0" anchor="ctr">
+            <a:spAutoFit/>
+          </a:bodyPr>
+          <a:lstStyle/>
+          <a:p>
+            <a:pPr algn="r">
+              <a:lnSpc>
+                <a:spcPct val="100000"/>
+              </a:lnSpc>
+              <a:spcBef>
+                <a:spcPts val="0"/>
+              </a:spcBef>
+              <a:spcAft>
+                <a:spcPts val="0"/>
+              </a:spcAft>
+            </a:pPr>
+            <a:r>
+              <a:rPr sz="630" b="0">
+                <a:solidFill>
+                  <a:srgbClr val="555555"/>
+                </a:solidFill>
+                <a:latin typeface="Consolas"/>
+              </a:rPr>
+              <a:t>inference/model.py · ScoreBasedMoE.forward</a:t>
+            </a:r>
+          </a:p>
+        </p:txBody>
+      </p:sp>
     </p:spTree>
   </p:cSld>
   <p:clrMapOvr>

</xml_diff>